<commit_message>
Add RabbitMQ real-time order pipeline
</commit_message>
<xml_diff>
--- a/docs/ECommerce_DuckDB_Case_Study_Presentation.pptx
+++ b/docs/ECommerce_DuckDB_Case_Study_Presentation.pptx
@@ -2,22 +2,22 @@
 <file path=ppt/presentation.xml><?xml version="1.0" encoding="utf-8"?>
 <p:presentation xmlns:p="http://schemas.openxmlformats.org/presentationml/2006/main">
   <p:sldMasterIdLst>
-    <p:sldMasterId xmlns:r="http://schemas.openxmlformats.org/officeDocument/2006/relationships" id="2147483648" r:id="Re4a1b980cc3b43b6"/>
+    <p:sldMasterId xmlns:r="http://schemas.openxmlformats.org/officeDocument/2006/relationships" id="2147483648" r:id="R2dc70bf3da0e4b65"/>
   </p:sldMasterIdLst>
   <p:notesMasterIdLst>
-    <p:notesMasterId xmlns:r="http://schemas.openxmlformats.org/officeDocument/2006/relationships" r:id="Re985eb4aba16480a"/>
+    <p:notesMasterId xmlns:r="http://schemas.openxmlformats.org/officeDocument/2006/relationships" r:id="R126287f21fd3419b"/>
   </p:notesMasterIdLst>
   <p:sldIdLst>
-    <p:sldId xmlns:r="http://schemas.openxmlformats.org/officeDocument/2006/relationships" id="256" r:id="R0cc5cd5cb722405c"/>
-    <p:sldId xmlns:r="http://schemas.openxmlformats.org/officeDocument/2006/relationships" id="257" r:id="R935814957c684948"/>
-    <p:sldId xmlns:r="http://schemas.openxmlformats.org/officeDocument/2006/relationships" id="258" r:id="Rc3ef6fb9d8fb4484"/>
-    <p:sldId xmlns:r="http://schemas.openxmlformats.org/officeDocument/2006/relationships" id="259" r:id="R8ac8c5f5ef0b4717"/>
-    <p:sldId xmlns:r="http://schemas.openxmlformats.org/officeDocument/2006/relationships" id="260" r:id="R81e04d316e724668"/>
-    <p:sldId xmlns:r="http://schemas.openxmlformats.org/officeDocument/2006/relationships" id="261" r:id="Rcc3116fbc2ab4af1"/>
-    <p:sldId xmlns:r="http://schemas.openxmlformats.org/officeDocument/2006/relationships" id="262" r:id="Re3d59da7476a44e3"/>
-    <p:sldId xmlns:r="http://schemas.openxmlformats.org/officeDocument/2006/relationships" id="263" r:id="R024ff67a7d38411f"/>
-    <p:sldId xmlns:r="http://schemas.openxmlformats.org/officeDocument/2006/relationships" id="264" r:id="R781f2f0bc3544f89"/>
-    <p:sldId xmlns:r="http://schemas.openxmlformats.org/officeDocument/2006/relationships" id="265" r:id="R88e05110d0074c63"/>
+    <p:sldId xmlns:r="http://schemas.openxmlformats.org/officeDocument/2006/relationships" id="256" r:id="R70a81f466096446e"/>
+    <p:sldId xmlns:r="http://schemas.openxmlformats.org/officeDocument/2006/relationships" id="257" r:id="R91599353ca114ced"/>
+    <p:sldId xmlns:r="http://schemas.openxmlformats.org/officeDocument/2006/relationships" id="258" r:id="Rd49a3db29a434bdb"/>
+    <p:sldId xmlns:r="http://schemas.openxmlformats.org/officeDocument/2006/relationships" id="259" r:id="R67e65ceb492347fc"/>
+    <p:sldId xmlns:r="http://schemas.openxmlformats.org/officeDocument/2006/relationships" id="260" r:id="R128ba636bb8f4908"/>
+    <p:sldId xmlns:r="http://schemas.openxmlformats.org/officeDocument/2006/relationships" id="261" r:id="Rabd4d08b8a24492a"/>
+    <p:sldId xmlns:r="http://schemas.openxmlformats.org/officeDocument/2006/relationships" id="262" r:id="R684c7f27674d4794"/>
+    <p:sldId xmlns:r="http://schemas.openxmlformats.org/officeDocument/2006/relationships" id="263" r:id="Rf24d7a02f6cc4366"/>
+    <p:sldId xmlns:r="http://schemas.openxmlformats.org/officeDocument/2006/relationships" id="264" r:id="R93e142d9d9184487"/>
+    <p:sldId xmlns:r="http://schemas.openxmlformats.org/officeDocument/2006/relationships" id="265" r:id="Raf6eb91ffb574a61"/>
   </p:sldIdLst>
   <p:sldSz cx="12192000" cy="6858000"/>
   <p:notesSz cx="6858000" cy="9144000"/>
@@ -451,7 +451,7 @@
           <a:lstStyle xmlns:a="http://schemas.openxmlformats.org/drawingml/2006/main"/>
           <a:p xmlns:a="http://schemas.openxmlformats.org/drawingml/2006/main">
             <a:r>
-              <a:t>Introduce the practical topic and explain that every displayed number comes from the reproducible 250,000-row evidence run.</a:t>
+              <a:t>Introduce the batch case study first, then state that the bonus path captures new orders through FastAPI and RabbitMQ.</a:t>
             </a:r>
           </a:p>
         </p:txBody>
@@ -661,7 +661,17 @@
           <a:lstStyle xmlns:a="http://schemas.openxmlformats.org/drawingml/2006/main"/>
           <a:p xmlns:a="http://schemas.openxmlformats.org/drawingml/2006/main">
             <a:r>
-              <a:t>Walk left to right. Point out that the architecture is local and reproducible, while the container and Kubernetes files make the presentation layer deployable.</a:t>
+              <a:t>Walk left to right. The historical path and live path converge in DuckDB, while the API owns the writable real-time file in one process.</a:t>
+            </a:r>
+          </a:p>
+          <a:p xmlns:a="http://schemas.openxmlformats.org/drawingml/2006/main">
+            <a:r>
+              <a:t/>
+            </a:r>
+          </a:p>
+          <a:p xmlns:a="http://schemas.openxmlformats.org/drawingml/2006/main">
+            <a:r>
+              <a:t>Source: https://duckdb.org/docs/current/connect/concurrency</a:t>
             </a:r>
           </a:p>
         </p:txBody>
@@ -941,7 +951,7 @@
           <a:lstStyle xmlns:a="http://schemas.openxmlformats.org/drawingml/2006/main"/>
           <a:p xmlns:a="http://schemas.openxmlformats.org/drawingml/2006/main">
             <a:r>
-              <a:t>Demo the live application if time allows. The screenshot documents the verified local run.</a:t>
+              <a:t>Demo the historical filters, then scroll to the live panel. The live panel requests API metrics every five seconds.</a:t>
             </a:r>
           </a:p>
         </p:txBody>
@@ -1101,7 +1111,7 @@
           <a:lstStyle xmlns:a="http://schemas.openxmlformats.org/drawingml/2006/main"/>
           <a:p xmlns:a="http://schemas.openxmlformats.org/drawingml/2006/main">
             <a:r>
-              <a:t>This slide maps every bonus criterion to implemented evidence. The API is a public test service and the Kubernetes files are deployment assets for Minikube, kind or another cluster.</a:t>
+              <a:t>This slide maps every bonus criterion to evidence. Unit tests, API metrics, Compose parsing and Kustomize rendering passed. Docker Desktop crashed before its Linux engine started, so the report does not claim a successful RabbitMQ container run on the authoring host.</a:t>
             </a:r>
           </a:p>
           <a:p xmlns:a="http://schemas.openxmlformats.org/drawingml/2006/main">
@@ -1111,7 +1121,7 @@
           </a:p>
           <a:p xmlns:a="http://schemas.openxmlformats.org/drawingml/2006/main">
             <a:r>
-              <a:t>Source: https://dummyjson.com/docs/products</a:t>
+              <a:t>Source: https://www.rabbitmq.com/docs/confirms</a:t>
             </a:r>
           </a:p>
           <a:p xmlns:a="http://schemas.openxmlformats.org/drawingml/2006/main">
@@ -1121,7 +1131,7 @@
           </a:p>
           <a:p xmlns:a="http://schemas.openxmlformats.org/drawingml/2006/main">
             <a:r>
-              <a:t>Source: https://dummyjson.com/docs/carts</a:t>
+              <a:t>Source: https://fastapi.tiangolo.com/tutorial/body/</a:t>
             </a:r>
           </a:p>
           <a:p xmlns:a="http://schemas.openxmlformats.org/drawingml/2006/main">
@@ -1178,7 +1188,7 @@
           <p:cNvPr id="3" name="Title">
             <a:extLst xmlns:a="http://schemas.openxmlformats.org/drawingml/2006/main">
               <a:ext uri="{FF2B5EF4-FFF2-40B4-BE49-F238E27FC236}">
-                <a16:creationId xmlns:a16="http://schemas.microsoft.com/office/drawing/2014/main" id="{B66BEF29-6624-4E84-B9E3-81AFA7205C67}"/>
+                <a16:creationId xmlns:a16="http://schemas.microsoft.com/office/drawing/2014/main" id="{9406AF69-FC72-4883-B5EF-54C72122F27E}"/>
               </a:ext>
             </a:extLst>
           </p:cNvPr>
@@ -1335,7 +1345,7 @@
           <p:cNvPr id="2" name="Subtitle">
             <a:extLst xmlns:a="http://schemas.openxmlformats.org/drawingml/2006/main">
               <a:ext uri="{FF2B5EF4-FFF2-40B4-BE49-F238E27FC236}">
-                <a16:creationId xmlns:a16="http://schemas.microsoft.com/office/drawing/2014/main" id="{E53FBC3A-FA9B-425A-8D5E-D5234CE23310}"/>
+                <a16:creationId xmlns:a16="http://schemas.microsoft.com/office/drawing/2014/main" id="{E77AE873-94CB-4864-968B-C9713F28CF69}"/>
               </a:ext>
             </a:extLst>
           </p:cNvPr>
@@ -1509,7 +1519,7 @@
           <p:cNvPr id="2" name="Section title">
             <a:extLst xmlns:a="http://schemas.openxmlformats.org/drawingml/2006/main">
               <a:ext uri="{FF2B5EF4-FFF2-40B4-BE49-F238E27FC236}">
-                <a16:creationId xmlns:a16="http://schemas.microsoft.com/office/drawing/2014/main" id="{DFB40819-F270-4120-AAD4-D6BDD1CDC570}"/>
+                <a16:creationId xmlns:a16="http://schemas.microsoft.com/office/drawing/2014/main" id="{43642908-2ACF-4A05-851D-AABAC009FB82}"/>
               </a:ext>
             </a:extLst>
           </p:cNvPr>
@@ -1683,7 +1693,7 @@
           <p:cNvPr id="3" name="Title">
             <a:extLst xmlns:a="http://schemas.openxmlformats.org/drawingml/2006/main">
               <a:ext uri="{FF2B5EF4-FFF2-40B4-BE49-F238E27FC236}">
-                <a16:creationId xmlns:a16="http://schemas.microsoft.com/office/drawing/2014/main" id="{6E9677EE-F45E-4D77-B2CE-5294E07B961E}"/>
+                <a16:creationId xmlns:a16="http://schemas.microsoft.com/office/drawing/2014/main" id="{AEC28D22-0A0C-440E-9D02-D630334592DF}"/>
               </a:ext>
             </a:extLst>
           </p:cNvPr>
@@ -1840,7 +1850,7 @@
           <p:cNvPr id="2" name="Body">
             <a:extLst xmlns:a="http://schemas.openxmlformats.org/drawingml/2006/main">
               <a:ext uri="{FF2B5EF4-FFF2-40B4-BE49-F238E27FC236}">
-                <a16:creationId xmlns:a16="http://schemas.microsoft.com/office/drawing/2014/main" id="{3386BCED-271E-4533-946C-9BE691E8B256}"/>
+                <a16:creationId xmlns:a16="http://schemas.microsoft.com/office/drawing/2014/main" id="{C8958065-D902-4E52-B5B3-C7B7C73EEB86}"/>
               </a:ext>
             </a:extLst>
           </p:cNvPr>
@@ -2014,7 +2024,7 @@
           <p:cNvPr id="4" name="Title">
             <a:extLst xmlns:a="http://schemas.openxmlformats.org/drawingml/2006/main">
               <a:ext uri="{FF2B5EF4-FFF2-40B4-BE49-F238E27FC236}">
-                <a16:creationId xmlns:a16="http://schemas.microsoft.com/office/drawing/2014/main" id="{EC7B3720-84E9-47C5-8ADD-F51A51442E61}"/>
+                <a16:creationId xmlns:a16="http://schemas.microsoft.com/office/drawing/2014/main" id="{AA40BC77-B056-4047-B111-71543FCCD2BA}"/>
               </a:ext>
             </a:extLst>
           </p:cNvPr>
@@ -2171,7 +2181,7 @@
           <p:cNvPr id="2" name="Left column">
             <a:extLst xmlns:a="http://schemas.openxmlformats.org/drawingml/2006/main">
               <a:ext uri="{FF2B5EF4-FFF2-40B4-BE49-F238E27FC236}">
-                <a16:creationId xmlns:a16="http://schemas.microsoft.com/office/drawing/2014/main" id="{3E30F01C-895C-45F0-AA7D-4B964B0AC2D7}"/>
+                <a16:creationId xmlns:a16="http://schemas.microsoft.com/office/drawing/2014/main" id="{A4B535B7-5543-4378-850D-EF1A178958BE}"/>
               </a:ext>
             </a:extLst>
           </p:cNvPr>
@@ -2328,7 +2338,7 @@
           <p:cNvPr id="3" name="Right column">
             <a:extLst xmlns:a="http://schemas.openxmlformats.org/drawingml/2006/main">
               <a:ext uri="{FF2B5EF4-FFF2-40B4-BE49-F238E27FC236}">
-                <a16:creationId xmlns:a16="http://schemas.microsoft.com/office/drawing/2014/main" id="{8988D048-E8D4-4BA5-85FD-52C81C5BFC1A}"/>
+                <a16:creationId xmlns:a16="http://schemas.microsoft.com/office/drawing/2014/main" id="{CC3FD372-C710-4988-8277-DB19AE89624E}"/>
               </a:ext>
             </a:extLst>
           </p:cNvPr>
@@ -2502,7 +2512,7 @@
           <p:cNvPr id="3" name="Title">
             <a:extLst xmlns:a="http://schemas.openxmlformats.org/drawingml/2006/main">
               <a:ext uri="{FF2B5EF4-FFF2-40B4-BE49-F238E27FC236}">
-                <a16:creationId xmlns:a16="http://schemas.microsoft.com/office/drawing/2014/main" id="{50B4CD6D-5166-48B7-A990-975C81FE1FDD}"/>
+                <a16:creationId xmlns:a16="http://schemas.microsoft.com/office/drawing/2014/main" id="{0C8DE5B5-A8C8-42E1-B0FF-05E1320A217B}"/>
               </a:ext>
             </a:extLst>
           </p:cNvPr>
@@ -2659,7 +2669,7 @@
           <p:cNvPr id="2" name="Left column">
             <a:extLst xmlns:a="http://schemas.openxmlformats.org/drawingml/2006/main">
               <a:ext uri="{FF2B5EF4-FFF2-40B4-BE49-F238E27FC236}">
-                <a16:creationId xmlns:a16="http://schemas.microsoft.com/office/drawing/2014/main" id="{EFE02E55-E87D-432D-98A5-91439A0A6647}"/>
+                <a16:creationId xmlns:a16="http://schemas.microsoft.com/office/drawing/2014/main" id="{F599DC38-95FE-473F-81B2-4BA491ECA513}"/>
               </a:ext>
             </a:extLst>
           </p:cNvPr>
@@ -2854,12 +2864,12 @@
   </p:cSld>
   <p:clrMap bg1="lt1" tx1="dk1" bg2="lt2" tx2="dk2" accent1="accent1" accent2="accent2" accent3="accent3" accent4="accent4" accent5="accent5" accent6="accent6" hlink="hlink" folHlink="folHlink"/>
   <p:sldLayoutIdLst>
-    <p:sldLayoutId xmlns:r="http://schemas.openxmlformats.org/officeDocument/2006/relationships" id="2147483649" r:id="R188cd5d12b1b4140"/>
-    <p:sldLayoutId xmlns:r="http://schemas.openxmlformats.org/officeDocument/2006/relationships" id="2147483650" r:id="R81164f2c49c44498"/>
-    <p:sldLayoutId xmlns:r="http://schemas.openxmlformats.org/officeDocument/2006/relationships" id="2147483651" r:id="Rc72b469cf98142fe"/>
-    <p:sldLayoutId xmlns:r="http://schemas.openxmlformats.org/officeDocument/2006/relationships" id="2147483652" r:id="R8613f988af41436c"/>
-    <p:sldLayoutId xmlns:r="http://schemas.openxmlformats.org/officeDocument/2006/relationships" id="2147483653" r:id="R4744cd215fee40fa"/>
-    <p:sldLayoutId xmlns:r="http://schemas.openxmlformats.org/officeDocument/2006/relationships" id="2147483654" r:id="R5e085591bc704668"/>
+    <p:sldLayoutId xmlns:r="http://schemas.openxmlformats.org/officeDocument/2006/relationships" id="2147483649" r:id="Ra46e3b0b96f941a3"/>
+    <p:sldLayoutId xmlns:r="http://schemas.openxmlformats.org/officeDocument/2006/relationships" id="2147483650" r:id="R93af4c6c79cc4e64"/>
+    <p:sldLayoutId xmlns:r="http://schemas.openxmlformats.org/officeDocument/2006/relationships" id="2147483651" r:id="Rd5ae57b1cfee4b22"/>
+    <p:sldLayoutId xmlns:r="http://schemas.openxmlformats.org/officeDocument/2006/relationships" id="2147483652" r:id="R14c93ddadcab4a47"/>
+    <p:sldLayoutId xmlns:r="http://schemas.openxmlformats.org/officeDocument/2006/relationships" id="2147483653" r:id="Raee54a2981ed4009"/>
+    <p:sldLayoutId xmlns:r="http://schemas.openxmlformats.org/officeDocument/2006/relationships" id="2147483654" r:id="R8b0fbbac28ee447a"/>
   </p:sldLayoutIdLst>
   <p:txStyles>
     <p:titleStyle>
@@ -3913,7 +3923,7 @@
           <p:cNvPr id="10" name="">
             <a:extLst xmlns:a="http://schemas.openxmlformats.org/drawingml/2006/main">
               <a:ext uri="{FF2B5EF4-FFF2-40B4-BE49-F238E27FC236}">
-                <a16:creationId xmlns:a16="http://schemas.microsoft.com/office/drawing/2014/main" id="{172D25D1-AE41-4FFA-BBD5-246999B1116A}"/>
+                <a16:creationId xmlns:a16="http://schemas.microsoft.com/office/drawing/2014/main" id="{72232773-85A5-4368-83B1-4FCC91211B96}"/>
               </a:ext>
             </a:extLst>
           </p:cNvPr>
@@ -3980,7 +3990,7 @@
           <p:cNvPr id="2" name="">
             <a:extLst xmlns:a="http://schemas.openxmlformats.org/drawingml/2006/main">
               <a:ext uri="{FF2B5EF4-FFF2-40B4-BE49-F238E27FC236}">
-                <a16:creationId xmlns:a16="http://schemas.microsoft.com/office/drawing/2014/main" id="{F8FC0547-4935-49F3-BB4D-A3120616F17A}"/>
+                <a16:creationId xmlns:a16="http://schemas.microsoft.com/office/drawing/2014/main" id="{38F138FB-E017-4BCD-8DD2-29A710241096}"/>
               </a:ext>
             </a:extLst>
           </p:cNvPr>
@@ -4070,7 +4080,7 @@
           <p:cNvPr id="3" name="">
             <a:extLst xmlns:a="http://schemas.openxmlformats.org/drawingml/2006/main">
               <a:ext uri="{FF2B5EF4-FFF2-40B4-BE49-F238E27FC236}">
-                <a16:creationId xmlns:a16="http://schemas.microsoft.com/office/drawing/2014/main" id="{BC0D16EF-369F-4E3B-8F73-3D00741F72D4}"/>
+                <a16:creationId xmlns:a16="http://schemas.microsoft.com/office/drawing/2014/main" id="{3932E36D-D72E-4943-95A7-6A02457F741A}"/>
               </a:ext>
             </a:extLst>
           </p:cNvPr>
@@ -4127,7 +4137,7 @@
                 <a:ea typeface="Arial"/>
                 <a:cs typeface="Arial"/>
               </a:rPr>
-              <a:t>A reproducible analytics platform built with Python, SQL, Parquet and Streamlit</a:t>
+              <a:t>Batch analytics plus validated real-time order ingestion</a:t>
             </a:r>
           </a:p>
         </p:txBody>
@@ -4137,7 +4147,7 @@
           <p:cNvPr id="4" name="">
             <a:extLst xmlns:a="http://schemas.openxmlformats.org/drawingml/2006/main">
               <a:ext uri="{FF2B5EF4-FFF2-40B4-BE49-F238E27FC236}">
-                <a16:creationId xmlns:a16="http://schemas.microsoft.com/office/drawing/2014/main" id="{993E1041-2124-4189-8AB2-EC936C5DEBEF}"/>
+                <a16:creationId xmlns:a16="http://schemas.microsoft.com/office/drawing/2014/main" id="{1D135CF7-1322-4E3F-9058-49300504BFAE}"/>
               </a:ext>
             </a:extLst>
           </p:cNvPr>
@@ -4170,7 +4180,7 @@
           <p:cNvPr id="5" name="">
             <a:extLst xmlns:a="http://schemas.openxmlformats.org/drawingml/2006/main">
               <a:ext uri="{FF2B5EF4-FFF2-40B4-BE49-F238E27FC236}">
-                <a16:creationId xmlns:a16="http://schemas.microsoft.com/office/drawing/2014/main" id="{58E97E74-7CF7-43B4-A5F1-3B066BDC44A3}"/>
+                <a16:creationId xmlns:a16="http://schemas.microsoft.com/office/drawing/2014/main" id="{2C32B62A-8A0B-4629-BAA1-3BFF9CBF5CBD}"/>
               </a:ext>
             </a:extLst>
           </p:cNvPr>
@@ -4237,7 +4247,7 @@
           <p:cNvPr id="6" name="">
             <a:extLst xmlns:a="http://schemas.openxmlformats.org/drawingml/2006/main">
               <a:ext uri="{FF2B5EF4-FFF2-40B4-BE49-F238E27FC236}">
-                <a16:creationId xmlns:a16="http://schemas.microsoft.com/office/drawing/2014/main" id="{4AF161C4-31AD-4781-AD51-322354A62778}"/>
+                <a16:creationId xmlns:a16="http://schemas.microsoft.com/office/drawing/2014/main" id="{7F505BAE-F996-46B0-AAA4-D4C58F5C3579}"/>
               </a:ext>
             </a:extLst>
           </p:cNvPr>
@@ -4304,7 +4314,7 @@
           <p:cNvPr id="7" name="">
             <a:extLst xmlns:a="http://schemas.openxmlformats.org/drawingml/2006/main">
               <a:ext uri="{FF2B5EF4-FFF2-40B4-BE49-F238E27FC236}">
-                <a16:creationId xmlns:a16="http://schemas.microsoft.com/office/drawing/2014/main" id="{92CEA15F-64B1-420A-B723-4F42DF13AA23}"/>
+                <a16:creationId xmlns:a16="http://schemas.microsoft.com/office/drawing/2014/main" id="{21786C3A-6354-4D37-A4E5-29199EF1D687}"/>
               </a:ext>
             </a:extLst>
           </p:cNvPr>
@@ -4371,7 +4381,7 @@
           <p:cNvPr id="8" name="">
             <a:extLst xmlns:a="http://schemas.openxmlformats.org/drawingml/2006/main">
               <a:ext uri="{FF2B5EF4-FFF2-40B4-BE49-F238E27FC236}">
-                <a16:creationId xmlns:a16="http://schemas.microsoft.com/office/drawing/2014/main" id="{D40AF358-7FA9-4580-93EC-B52736961721}"/>
+                <a16:creationId xmlns:a16="http://schemas.microsoft.com/office/drawing/2014/main" id="{087A4AC7-AB9F-4741-B55F-D20F5CF2D156}"/>
               </a:ext>
             </a:extLst>
           </p:cNvPr>
@@ -4438,7 +4448,7 @@
           <p:cNvPr id="9" name="">
             <a:extLst xmlns:a="http://schemas.openxmlformats.org/drawingml/2006/main">
               <a:ext uri="{FF2B5EF4-FFF2-40B4-BE49-F238E27FC236}">
-                <a16:creationId xmlns:a16="http://schemas.microsoft.com/office/drawing/2014/main" id="{5E6DBE9C-7786-4772-A1FB-414CB7D87609}"/>
+                <a16:creationId xmlns:a16="http://schemas.microsoft.com/office/drawing/2014/main" id="{D0C4CFAC-729D-42E4-80B9-4358DDEC1E1B}"/>
               </a:ext>
             </a:extLst>
           </p:cNvPr>
@@ -4450,7 +4460,7 @@
         <p:spPr>
           <a:xfrm xmlns:a="http://schemas.openxmlformats.org/drawingml/2006/main">
             <a:off x="742950" y="5924550"/>
-            <a:ext cx="8763000" cy="266700"/>
+            <a:ext cx="9334500" cy="266700"/>
           </a:xfrm>
           <a:prstGeom xmlns:a="http://schemas.openxmlformats.org/drawingml/2006/main" prst="rect">
             <a:avLst/>
@@ -4495,7 +4505,7 @@
                 <a:ea typeface="Arial"/>
                 <a:cs typeface="Arial"/>
               </a:rPr>
-              <a:t>Bonus: API ingestion  |  Kubernetes  |  execution-mode benchmark</a:t>
+              <a:t>Bonus: RabbitMQ streaming  |  Kubernetes  |  execution-mode benchmark</a:t>
             </a:r>
           </a:p>
         </p:txBody>
@@ -4503,7 +4513,7 @@
     </p:spTree>
     <p:extLst>
       <p:ext uri="{BB962C8B-B14F-4D97-AF65-F5344CB8AC3E}">
-        <p14:creationId xmlns:p14="http://schemas.microsoft.com/office/powerpoint/2010/main" val="885927419"/>
+        <p14:creationId xmlns:p14="http://schemas.microsoft.com/office/powerpoint/2010/main" val="1596855163"/>
       </p:ext>
     </p:extLst>
   </p:cSld>
@@ -4534,7 +4544,7 @@
           <p:cNvPr id="18" name="">
             <a:extLst xmlns:a="http://schemas.openxmlformats.org/drawingml/2006/main">
               <a:ext uri="{FF2B5EF4-FFF2-40B4-BE49-F238E27FC236}">
-                <a16:creationId xmlns:a16="http://schemas.microsoft.com/office/drawing/2014/main" id="{B38AB80B-FF48-40B9-BB51-0C0601CB8447}"/>
+                <a16:creationId xmlns:a16="http://schemas.microsoft.com/office/drawing/2014/main" id="{A756CBFE-5B84-4CB9-AE06-063B52C76736}"/>
               </a:ext>
             </a:extLst>
           </p:cNvPr>
@@ -4601,7 +4611,7 @@
           <p:cNvPr id="2" name="">
             <a:extLst xmlns:a="http://schemas.openxmlformats.org/drawingml/2006/main">
               <a:ext uri="{FF2B5EF4-FFF2-40B4-BE49-F238E27FC236}">
-                <a16:creationId xmlns:a16="http://schemas.microsoft.com/office/drawing/2014/main" id="{EEF0AAEF-BD15-4331-BA1D-EF45525C83FC}"/>
+                <a16:creationId xmlns:a16="http://schemas.microsoft.com/office/drawing/2014/main" id="{7CCFEAA4-017D-450D-9601-431D7467B0B1}"/>
               </a:ext>
             </a:extLst>
           </p:cNvPr>
@@ -4658,7 +4668,7 @@
                 <a:ea typeface="Arial"/>
                 <a:cs typeface="Arial"/>
               </a:rPr>
-              <a:t>The practical covers the full analytical path</a:t>
+              <a:t>Batch analytics and live ingestion in one platform</a:t>
             </a:r>
           </a:p>
         </p:txBody>
@@ -4668,7 +4678,7 @@
           <p:cNvPr id="3" name="">
             <a:extLst xmlns:a="http://schemas.openxmlformats.org/drawingml/2006/main">
               <a:ext uri="{FF2B5EF4-FFF2-40B4-BE49-F238E27FC236}">
-                <a16:creationId xmlns:a16="http://schemas.microsoft.com/office/drawing/2014/main" id="{0B48ADAB-DA98-4CE6-849B-C8E220CCF009}"/>
+                <a16:creationId xmlns:a16="http://schemas.microsoft.com/office/drawing/2014/main" id="{F623ED65-31EF-47B0-A913-100FA7C3CD6D}"/>
               </a:ext>
             </a:extLst>
           </p:cNvPr>
@@ -4735,7 +4745,7 @@
           <p:cNvPr id="4" name="">
             <a:extLst xmlns:a="http://schemas.openxmlformats.org/drawingml/2006/main">
               <a:ext uri="{FF2B5EF4-FFF2-40B4-BE49-F238E27FC236}">
-                <a16:creationId xmlns:a16="http://schemas.microsoft.com/office/drawing/2014/main" id="{957835A1-C4D7-4974-AA7D-72E9A3B823EA}"/>
+                <a16:creationId xmlns:a16="http://schemas.microsoft.com/office/drawing/2014/main" id="{D17DF50F-4BC9-4B2F-8C4A-BDE22B2A94EA}"/>
               </a:ext>
             </a:extLst>
           </p:cNvPr>
@@ -4802,7 +4812,7 @@
           <p:cNvPr id="5" name="">
             <a:extLst xmlns:a="http://schemas.openxmlformats.org/drawingml/2006/main">
               <a:ext uri="{FF2B5EF4-FFF2-40B4-BE49-F238E27FC236}">
-                <a16:creationId xmlns:a16="http://schemas.microsoft.com/office/drawing/2014/main" id="{A0FCDEAC-1B8D-4B4E-8A44-6C4A3D97F77A}"/>
+                <a16:creationId xmlns:a16="http://schemas.microsoft.com/office/drawing/2014/main" id="{D4FDF421-0DCC-4652-A850-166027A9640F}"/>
               </a:ext>
             </a:extLst>
           </p:cNvPr>
@@ -4869,7 +4879,7 @@
           <p:cNvPr id="6" name="">
             <a:extLst xmlns:a="http://schemas.openxmlformats.org/drawingml/2006/main">
               <a:ext uri="{FF2B5EF4-FFF2-40B4-BE49-F238E27FC236}">
-                <a16:creationId xmlns:a16="http://schemas.microsoft.com/office/drawing/2014/main" id="{3C566BFF-8240-466C-B0E1-3A1BC1F35755}"/>
+                <a16:creationId xmlns:a16="http://schemas.microsoft.com/office/drawing/2014/main" id="{8F5D4403-AC52-41EB-B806-26AE43CAF0A2}"/>
               </a:ext>
             </a:extLst>
           </p:cNvPr>
@@ -4936,7 +4946,7 @@
           <p:cNvPr id="7" name="">
             <a:extLst xmlns:a="http://schemas.openxmlformats.org/drawingml/2006/main">
               <a:ext uri="{FF2B5EF4-FFF2-40B4-BE49-F238E27FC236}">
-                <a16:creationId xmlns:a16="http://schemas.microsoft.com/office/drawing/2014/main" id="{15C52216-4D15-4325-9AB9-35F2A24A8774}"/>
+                <a16:creationId xmlns:a16="http://schemas.microsoft.com/office/drawing/2014/main" id="{5D0B24C2-D982-4A8F-BD09-D312E62D5D34}"/>
               </a:ext>
             </a:extLst>
           </p:cNvPr>
@@ -4969,7 +4979,7 @@
           <p:cNvPr id="8" name="">
             <a:extLst xmlns:a="http://schemas.openxmlformats.org/drawingml/2006/main">
               <a:ext uri="{FF2B5EF4-FFF2-40B4-BE49-F238E27FC236}">
-                <a16:creationId xmlns:a16="http://schemas.microsoft.com/office/drawing/2014/main" id="{175E6B94-9F04-4240-A84E-28AF3613E50B}"/>
+                <a16:creationId xmlns:a16="http://schemas.microsoft.com/office/drawing/2014/main" id="{8FE4D61D-D894-4515-986D-4BDE9DC13C50}"/>
               </a:ext>
             </a:extLst>
           </p:cNvPr>
@@ -5002,7 +5012,7 @@
           <p:cNvPr id="9" name="">
             <a:extLst xmlns:a="http://schemas.openxmlformats.org/drawingml/2006/main">
               <a:ext uri="{FF2B5EF4-FFF2-40B4-BE49-F238E27FC236}">
-                <a16:creationId xmlns:a16="http://schemas.microsoft.com/office/drawing/2014/main" id="{4F2FC07F-871C-4D7B-86B7-4EA995C8DA77}"/>
+                <a16:creationId xmlns:a16="http://schemas.microsoft.com/office/drawing/2014/main" id="{5C34FDA7-8242-4F3D-B999-E0848C60F745}"/>
               </a:ext>
             </a:extLst>
           </p:cNvPr>
@@ -5035,7 +5045,7 @@
           <p:cNvPr id="10" name="">
             <a:extLst xmlns:a="http://schemas.openxmlformats.org/drawingml/2006/main">
               <a:ext uri="{FF2B5EF4-FFF2-40B4-BE49-F238E27FC236}">
-                <a16:creationId xmlns:a16="http://schemas.microsoft.com/office/drawing/2014/main" id="{5BB6B875-22E6-44F1-A0A9-82304676C788}"/>
+                <a16:creationId xmlns:a16="http://schemas.microsoft.com/office/drawing/2014/main" id="{B9D437B9-394C-4E9F-B0BF-EB317C08E644}"/>
               </a:ext>
             </a:extLst>
           </p:cNvPr>
@@ -5102,7 +5112,7 @@
           <p:cNvPr id="11" name="">
             <a:extLst xmlns:a="http://schemas.openxmlformats.org/drawingml/2006/main">
               <a:ext uri="{FF2B5EF4-FFF2-40B4-BE49-F238E27FC236}">
-                <a16:creationId xmlns:a16="http://schemas.microsoft.com/office/drawing/2014/main" id="{CC305BDD-FF73-4EBF-94B5-FCE45557F715}"/>
+                <a16:creationId xmlns:a16="http://schemas.microsoft.com/office/drawing/2014/main" id="{FA08B469-C678-4253-8D2F-D191D3389226}"/>
               </a:ext>
             </a:extLst>
           </p:cNvPr>
@@ -5169,7 +5179,7 @@
           <p:cNvPr id="12" name="">
             <a:extLst xmlns:a="http://schemas.openxmlformats.org/drawingml/2006/main">
               <a:ext uri="{FF2B5EF4-FFF2-40B4-BE49-F238E27FC236}">
-                <a16:creationId xmlns:a16="http://schemas.microsoft.com/office/drawing/2014/main" id="{7B1FE5FC-9CB8-4888-92BB-2570AA6BDA97}"/>
+                <a16:creationId xmlns:a16="http://schemas.microsoft.com/office/drawing/2014/main" id="{6A8D1FB9-B1BE-44B6-8AE5-E2F1C71D08CB}"/>
               </a:ext>
             </a:extLst>
           </p:cNvPr>
@@ -5236,7 +5246,7 @@
           <p:cNvPr id="13" name="">
             <a:extLst xmlns:a="http://schemas.openxmlformats.org/drawingml/2006/main">
               <a:ext uri="{FF2B5EF4-FFF2-40B4-BE49-F238E27FC236}">
-                <a16:creationId xmlns:a16="http://schemas.microsoft.com/office/drawing/2014/main" id="{247266DB-0F6C-4525-859A-9EB51D029F0D}"/>
+                <a16:creationId xmlns:a16="http://schemas.microsoft.com/office/drawing/2014/main" id="{0B090E4A-12A6-44A4-9E84-E046FAFC390D}"/>
               </a:ext>
             </a:extLst>
           </p:cNvPr>
@@ -5303,7 +5313,7 @@
           <p:cNvPr id="14" name="">
             <a:extLst xmlns:a="http://schemas.openxmlformats.org/drawingml/2006/main">
               <a:ext uri="{FF2B5EF4-FFF2-40B4-BE49-F238E27FC236}">
-                <a16:creationId xmlns:a16="http://schemas.microsoft.com/office/drawing/2014/main" id="{A592F874-A3C7-4E51-9BC4-1CDB25077ED5}"/>
+                <a16:creationId xmlns:a16="http://schemas.microsoft.com/office/drawing/2014/main" id="{8B909CD2-7011-4BD2-8CE1-77B26259B0A1}"/>
               </a:ext>
             </a:extLst>
           </p:cNvPr>
@@ -5370,7 +5380,7 @@
           <p:cNvPr id="15" name="">
             <a:extLst xmlns:a="http://schemas.openxmlformats.org/drawingml/2006/main">
               <a:ext uri="{FF2B5EF4-FFF2-40B4-BE49-F238E27FC236}">
-                <a16:creationId xmlns:a16="http://schemas.microsoft.com/office/drawing/2014/main" id="{0335C7AC-42F1-4517-B808-A08531D45BBA}"/>
+                <a16:creationId xmlns:a16="http://schemas.microsoft.com/office/drawing/2014/main" id="{A452BC6C-ED1D-4F4D-9067-0C40FE9D3781}"/>
               </a:ext>
             </a:extLst>
           </p:cNvPr>
@@ -5382,7 +5392,7 @@
         <p:spPr>
           <a:xfrm xmlns:a="http://schemas.openxmlformats.org/drawingml/2006/main">
             <a:off x="685800" y="4362450"/>
-            <a:ext cx="7048500" cy="1428750"/>
+            <a:ext cx="7048500" cy="1571625"/>
           </a:xfrm>
           <a:prstGeom xmlns:a="http://schemas.openxmlformats.org/drawingml/2006/main" prst="rect">
             <a:avLst/>
@@ -5397,7 +5407,7 @@
           <a:bodyPr xmlns:a="http://schemas.openxmlformats.org/drawingml/2006/main" anchor="ctr"/>
           <a:lstStyle xmlns:a="http://schemas.openxmlformats.org/drawingml/2006/main">
             <a:defPPr algn="l">
-              <a:defRPr sz="1575" b="0">
+              <a:defRPr sz="1500" b="0">
                 <a:solidFill>
                   <a:srgbClr val="FFFFFF"/>
                 </a:solidFill>
@@ -5409,7 +5419,7 @@
           </a:lstStyle>
           <a:p xmlns:a="http://schemas.openxmlformats.org/drawingml/2006/main">
             <a:pPr algn="l">
-              <a:defRPr sz="1575" b="0">
+              <a:defRPr sz="1500" b="0">
                 <a:solidFill>
                   <a:srgbClr val="FFFFFF"/>
                 </a:solidFill>
@@ -5419,7 +5429,7 @@
               </a:defRPr>
             </a:pPr>
             <a:r>
-              <a:rPr sz="1575" b="0">
+              <a:rPr sz="1500" b="0">
                 <a:solidFill>
                   <a:srgbClr val="FFFFFF"/>
                 </a:solidFill>
@@ -5427,12 +5437,12 @@
                 <a:ea typeface="Arial"/>
                 <a:cs typeface="Arial"/>
               </a:rPr>
-              <a:t>1. Run the CLI pipeline</a:t>
+              <a:t>1. Run the CLI batch pipeline</a:t>
             </a:r>
           </a:p>
           <a:p xmlns:a="http://schemas.openxmlformats.org/drawingml/2006/main">
             <a:pPr algn="l">
-              <a:defRPr sz="1575" b="0">
+              <a:defRPr sz="1500" b="0">
                 <a:solidFill>
                   <a:srgbClr val="FFFFFF"/>
                 </a:solidFill>
@@ -5442,7 +5452,7 @@
               </a:defRPr>
             </a:pPr>
             <a:r>
-              <a:rPr sz="1575" b="0">
+              <a:rPr sz="1500" b="0">
                 <a:solidFill>
                   <a:srgbClr val="FFFFFF"/>
                 </a:solidFill>
@@ -5450,12 +5460,12 @@
                 <a:ea typeface="Arial"/>
                 <a:cs typeface="Arial"/>
               </a:rPr>
-              <a:t>2. Open the generated quality and benchmark evidence</a:t>
+              <a:t>2. Open the quality and benchmark evidence</a:t>
             </a:r>
           </a:p>
           <a:p xmlns:a="http://schemas.openxmlformats.org/drawingml/2006/main">
             <a:pPr algn="l">
-              <a:defRPr sz="1575" b="0">
+              <a:defRPr sz="1500" b="0">
                 <a:solidFill>
                   <a:srgbClr val="FFFFFF"/>
                 </a:solidFill>
@@ -5465,7 +5475,7 @@
               </a:defRPr>
             </a:pPr>
             <a:r>
-              <a:rPr sz="1575" b="0">
+              <a:rPr sz="1500" b="0">
                 <a:solidFill>
                   <a:srgbClr val="FFFFFF"/>
                 </a:solidFill>
@@ -5473,12 +5483,12 @@
                 <a:ea typeface="Arial"/>
                 <a:cs typeface="Arial"/>
               </a:rPr>
-              <a:t>3. Start Streamlit and filter the KPIs</a:t>
+              <a:t>3. Start the Compose real-time profile</a:t>
             </a:r>
           </a:p>
           <a:p xmlns:a="http://schemas.openxmlformats.org/drawingml/2006/main">
             <a:pPr algn="l">
-              <a:defRPr sz="1575" b="0">
+              <a:defRPr sz="1500" b="0">
                 <a:solidFill>
                   <a:srgbClr val="FFFFFF"/>
                 </a:solidFill>
@@ -5488,7 +5498,7 @@
               </a:defRPr>
             </a:pPr>
             <a:r>
-              <a:rPr sz="1575" b="0">
+              <a:rPr sz="1500" b="0">
                 <a:solidFill>
                   <a:srgbClr val="FFFFFF"/>
                 </a:solidFill>
@@ -5496,7 +5506,30 @@
                 <a:ea typeface="Arial"/>
                 <a:cs typeface="Arial"/>
               </a:rPr>
-              <a:t>4. Show the API snapshot and Kubernetes manifests</a:t>
+              <a:t>4. Watch live orders update in Streamlit</a:t>
+            </a:r>
+          </a:p>
+          <a:p xmlns:a="http://schemas.openxmlformats.org/drawingml/2006/main">
+            <a:pPr algn="l">
+              <a:defRPr sz="1500" b="0">
+                <a:solidFill>
+                  <a:srgbClr val="FFFFFF"/>
+                </a:solidFill>
+                <a:latin typeface="Arial"/>
+                <a:ea typeface="Arial"/>
+                <a:cs typeface="Arial"/>
+              </a:defRPr>
+            </a:pPr>
+            <a:r>
+              <a:rPr sz="1500" b="0">
+                <a:solidFill>
+                  <a:srgbClr val="FFFFFF"/>
+                </a:solidFill>
+                <a:latin typeface="Arial"/>
+                <a:ea typeface="Arial"/>
+                <a:cs typeface="Arial"/>
+              </a:rPr>
+              <a:t>5. Show the Kubernetes resources</a:t>
             </a:r>
           </a:p>
         </p:txBody>
@@ -5506,7 +5539,7 @@
           <p:cNvPr id="16" name="">
             <a:extLst xmlns:a="http://schemas.openxmlformats.org/drawingml/2006/main">
               <a:ext uri="{FF2B5EF4-FFF2-40B4-BE49-F238E27FC236}">
-                <a16:creationId xmlns:a16="http://schemas.microsoft.com/office/drawing/2014/main" id="{1A7E8511-4A29-4BEC-9CC3-7632AEB1E2B5}"/>
+                <a16:creationId xmlns:a16="http://schemas.microsoft.com/office/drawing/2014/main" id="{FF6D8B55-D464-4191-9683-E9F3439EB148}"/>
               </a:ext>
             </a:extLst>
           </p:cNvPr>
@@ -5573,7 +5606,7 @@
           <p:cNvPr id="17" name="">
             <a:extLst xmlns:a="http://schemas.openxmlformats.org/drawingml/2006/main">
               <a:ext uri="{FF2B5EF4-FFF2-40B4-BE49-F238E27FC236}">
-                <a16:creationId xmlns:a16="http://schemas.microsoft.com/office/drawing/2014/main" id="{F6D2C851-1836-4A96-A82D-B92B241167AF}"/>
+                <a16:creationId xmlns:a16="http://schemas.microsoft.com/office/drawing/2014/main" id="{2A232DFA-1EFF-4B07-91E1-FEE0609A2CAB}"/>
               </a:ext>
             </a:extLst>
           </p:cNvPr>
@@ -5638,7 +5671,7 @@
     </p:spTree>
     <p:extLst>
       <p:ext uri="{BB962C8B-B14F-4D97-AF65-F5344CB8AC3E}">
-        <p14:creationId xmlns:p14="http://schemas.microsoft.com/office/powerpoint/2010/main" val="39480013"/>
+        <p14:creationId xmlns:p14="http://schemas.microsoft.com/office/powerpoint/2010/main" val="288989326"/>
       </p:ext>
     </p:extLst>
   </p:cSld>
@@ -5669,7 +5702,7 @@
           <p:cNvPr id="22" name="">
             <a:extLst xmlns:a="http://schemas.openxmlformats.org/drawingml/2006/main">
               <a:ext uri="{FF2B5EF4-FFF2-40B4-BE49-F238E27FC236}">
-                <a16:creationId xmlns:a16="http://schemas.microsoft.com/office/drawing/2014/main" id="{F3E0C0A8-CAC3-45DD-9AD6-D0D340FAF5AD}"/>
+                <a16:creationId xmlns:a16="http://schemas.microsoft.com/office/drawing/2014/main" id="{9A793859-1DB8-4B7C-B915-3320D38A328F}"/>
               </a:ext>
             </a:extLst>
           </p:cNvPr>
@@ -5736,7 +5769,7 @@
           <p:cNvPr id="2" name="">
             <a:extLst xmlns:a="http://schemas.openxmlformats.org/drawingml/2006/main">
               <a:ext uri="{FF2B5EF4-FFF2-40B4-BE49-F238E27FC236}">
-                <a16:creationId xmlns:a16="http://schemas.microsoft.com/office/drawing/2014/main" id="{8ADF8120-03B4-4C81-9871-551B32606C45}"/>
+                <a16:creationId xmlns:a16="http://schemas.microsoft.com/office/drawing/2014/main" id="{979A3564-C56A-4F3F-9D33-187E0B0DB879}"/>
               </a:ext>
             </a:extLst>
           </p:cNvPr>
@@ -5803,7 +5836,7 @@
           <p:cNvPr id="3" name="">
             <a:extLst xmlns:a="http://schemas.openxmlformats.org/drawingml/2006/main">
               <a:ext uri="{FF2B5EF4-FFF2-40B4-BE49-F238E27FC236}">
-                <a16:creationId xmlns:a16="http://schemas.microsoft.com/office/drawing/2014/main" id="{5DDA63E8-784F-48CD-921E-C1827BB43962}"/>
+                <a16:creationId xmlns:a16="http://schemas.microsoft.com/office/drawing/2014/main" id="{48E51F4C-C75B-4AEB-9876-3BF60C9EA333}"/>
               </a:ext>
             </a:extLst>
           </p:cNvPr>
@@ -5870,7 +5903,7 @@
           <p:cNvPr id="4" name="">
             <a:extLst xmlns:a="http://schemas.openxmlformats.org/drawingml/2006/main">
               <a:ext uri="{FF2B5EF4-FFF2-40B4-BE49-F238E27FC236}">
-                <a16:creationId xmlns:a16="http://schemas.microsoft.com/office/drawing/2014/main" id="{16C35D27-4E42-4E29-8373-49C7B0E33ED1}"/>
+                <a16:creationId xmlns:a16="http://schemas.microsoft.com/office/drawing/2014/main" id="{EEC15F79-DA5C-460A-A9E9-5E6D5B333D27}"/>
               </a:ext>
             </a:extLst>
           </p:cNvPr>
@@ -5937,7 +5970,7 @@
           <p:cNvPr id="5" name="">
             <a:extLst xmlns:a="http://schemas.openxmlformats.org/drawingml/2006/main">
               <a:ext uri="{FF2B5EF4-FFF2-40B4-BE49-F238E27FC236}">
-                <a16:creationId xmlns:a16="http://schemas.microsoft.com/office/drawing/2014/main" id="{22A2BAF6-BA7F-4C05-9E4E-0D7F3A68EF36}"/>
+                <a16:creationId xmlns:a16="http://schemas.microsoft.com/office/drawing/2014/main" id="{69FB8810-01A6-486A-B832-DA991F638CC7}"/>
               </a:ext>
             </a:extLst>
           </p:cNvPr>
@@ -6004,7 +6037,7 @@
           <p:cNvPr id="6" name="">
             <a:extLst xmlns:a="http://schemas.openxmlformats.org/drawingml/2006/main">
               <a:ext uri="{FF2B5EF4-FFF2-40B4-BE49-F238E27FC236}">
-                <a16:creationId xmlns:a16="http://schemas.microsoft.com/office/drawing/2014/main" id="{192159DB-757A-4CDF-A4EE-43E1D25B61A8}"/>
+                <a16:creationId xmlns:a16="http://schemas.microsoft.com/office/drawing/2014/main" id="{FB8E1506-8BDA-4971-975D-C277F8CEE15F}"/>
               </a:ext>
             </a:extLst>
           </p:cNvPr>
@@ -6071,7 +6104,7 @@
           <p:cNvPr id="7" name="">
             <a:extLst xmlns:a="http://schemas.openxmlformats.org/drawingml/2006/main">
               <a:ext uri="{FF2B5EF4-FFF2-40B4-BE49-F238E27FC236}">
-                <a16:creationId xmlns:a16="http://schemas.microsoft.com/office/drawing/2014/main" id="{B7750E8B-A2BA-4A27-A8D8-D257C5BE9C6F}"/>
+                <a16:creationId xmlns:a16="http://schemas.microsoft.com/office/drawing/2014/main" id="{28F31DD5-7D3E-42D7-822D-31FD2B5C9F2C}"/>
               </a:ext>
             </a:extLst>
           </p:cNvPr>
@@ -6138,7 +6171,7 @@
           <p:cNvPr id="8" name="">
             <a:extLst xmlns:a="http://schemas.openxmlformats.org/drawingml/2006/main">
               <a:ext uri="{FF2B5EF4-FFF2-40B4-BE49-F238E27FC236}">
-                <a16:creationId xmlns:a16="http://schemas.microsoft.com/office/drawing/2014/main" id="{605F6C8A-810B-43FE-9A19-12314FF4D757}"/>
+                <a16:creationId xmlns:a16="http://schemas.microsoft.com/office/drawing/2014/main" id="{AFA75531-A65B-4F55-A981-6E7C4B0943A6}"/>
               </a:ext>
             </a:extLst>
           </p:cNvPr>
@@ -6205,7 +6238,7 @@
           <p:cNvPr id="9" name="">
             <a:extLst xmlns:a="http://schemas.openxmlformats.org/drawingml/2006/main">
               <a:ext uri="{FF2B5EF4-FFF2-40B4-BE49-F238E27FC236}">
-                <a16:creationId xmlns:a16="http://schemas.microsoft.com/office/drawing/2014/main" id="{29D036C8-5D60-40ED-8755-073094C23F51}"/>
+                <a16:creationId xmlns:a16="http://schemas.microsoft.com/office/drawing/2014/main" id="{81DC1369-35FB-4722-911E-50589EB25852}"/>
               </a:ext>
             </a:extLst>
           </p:cNvPr>
@@ -6272,7 +6305,7 @@
           <p:cNvPr id="10" name="">
             <a:extLst xmlns:a="http://schemas.openxmlformats.org/drawingml/2006/main">
               <a:ext uri="{FF2B5EF4-FFF2-40B4-BE49-F238E27FC236}">
-                <a16:creationId xmlns:a16="http://schemas.microsoft.com/office/drawing/2014/main" id="{586E3B84-F04F-439B-A31E-DDD6A118FF0A}"/>
+                <a16:creationId xmlns:a16="http://schemas.microsoft.com/office/drawing/2014/main" id="{C16B542D-F229-49C7-8FDE-D04314DF3F95}"/>
               </a:ext>
             </a:extLst>
           </p:cNvPr>
@@ -6339,7 +6372,7 @@
           <p:cNvPr id="11" name="">
             <a:extLst xmlns:a="http://schemas.openxmlformats.org/drawingml/2006/main">
               <a:ext uri="{FF2B5EF4-FFF2-40B4-BE49-F238E27FC236}">
-                <a16:creationId xmlns:a16="http://schemas.microsoft.com/office/drawing/2014/main" id="{73F49E99-7193-4BD9-BB70-054CA2D50AAB}"/>
+                <a16:creationId xmlns:a16="http://schemas.microsoft.com/office/drawing/2014/main" id="{AF3E87DF-569A-4850-9EFE-84973A38D6D6}"/>
               </a:ext>
             </a:extLst>
           </p:cNvPr>
@@ -6406,7 +6439,7 @@
           <p:cNvPr id="12" name="">
             <a:extLst xmlns:a="http://schemas.openxmlformats.org/drawingml/2006/main">
               <a:ext uri="{FF2B5EF4-FFF2-40B4-BE49-F238E27FC236}">
-                <a16:creationId xmlns:a16="http://schemas.microsoft.com/office/drawing/2014/main" id="{32A3EB49-50BB-4046-9BF2-625B8FC462D9}"/>
+                <a16:creationId xmlns:a16="http://schemas.microsoft.com/office/drawing/2014/main" id="{BCAFD044-8103-47CF-BDE7-1B5738BDD691}"/>
               </a:ext>
             </a:extLst>
           </p:cNvPr>
@@ -6473,7 +6506,7 @@
           <p:cNvPr id="13" name="">
             <a:extLst xmlns:a="http://schemas.openxmlformats.org/drawingml/2006/main">
               <a:ext uri="{FF2B5EF4-FFF2-40B4-BE49-F238E27FC236}">
-                <a16:creationId xmlns:a16="http://schemas.microsoft.com/office/drawing/2014/main" id="{1D39CF24-2030-42F5-BFDA-358D62F11B3C}"/>
+                <a16:creationId xmlns:a16="http://schemas.microsoft.com/office/drawing/2014/main" id="{58CE7BAF-D3A7-4E46-9786-1DE859B08D53}"/>
               </a:ext>
             </a:extLst>
           </p:cNvPr>
@@ -6540,7 +6573,7 @@
           <p:cNvPr id="14" name="">
             <a:extLst xmlns:a="http://schemas.openxmlformats.org/drawingml/2006/main">
               <a:ext uri="{FF2B5EF4-FFF2-40B4-BE49-F238E27FC236}">
-                <a16:creationId xmlns:a16="http://schemas.microsoft.com/office/drawing/2014/main" id="{3A3016E1-4958-48F4-A6B2-ACF157B1CEB2}"/>
+                <a16:creationId xmlns:a16="http://schemas.microsoft.com/office/drawing/2014/main" id="{6F9ED1E6-A303-4332-A2BD-6408E2E9D6C5}"/>
               </a:ext>
             </a:extLst>
           </p:cNvPr>
@@ -6607,7 +6640,7 @@
           <p:cNvPr id="15" name="">
             <a:extLst xmlns:a="http://schemas.openxmlformats.org/drawingml/2006/main">
               <a:ext uri="{FF2B5EF4-FFF2-40B4-BE49-F238E27FC236}">
-                <a16:creationId xmlns:a16="http://schemas.microsoft.com/office/drawing/2014/main" id="{B6322585-977F-471F-998C-0622B134E6C9}"/>
+                <a16:creationId xmlns:a16="http://schemas.microsoft.com/office/drawing/2014/main" id="{DE404BF9-E0EB-4FD3-BC9F-8BF97B38607B}"/>
               </a:ext>
             </a:extLst>
           </p:cNvPr>
@@ -6680,7 +6713,7 @@
           <p:cNvPr id="16" name="">
             <a:extLst xmlns:a="http://schemas.openxmlformats.org/drawingml/2006/main">
               <a:ext uri="{FF2B5EF4-FFF2-40B4-BE49-F238E27FC236}">
-                <a16:creationId xmlns:a16="http://schemas.microsoft.com/office/drawing/2014/main" id="{A7810CA8-07A8-4E6F-A9C5-DCB965D0B749}"/>
+                <a16:creationId xmlns:a16="http://schemas.microsoft.com/office/drawing/2014/main" id="{FBBE7328-6715-49A0-BE3D-477FF7CFE491}"/>
               </a:ext>
             </a:extLst>
           </p:cNvPr>
@@ -6753,7 +6786,7 @@
           <p:cNvPr id="17" name="">
             <a:extLst xmlns:a="http://schemas.openxmlformats.org/drawingml/2006/main">
               <a:ext uri="{FF2B5EF4-FFF2-40B4-BE49-F238E27FC236}">
-                <a16:creationId xmlns:a16="http://schemas.microsoft.com/office/drawing/2014/main" id="{717B6D3B-1DAF-4973-A9D3-F932BA6294FB}"/>
+                <a16:creationId xmlns:a16="http://schemas.microsoft.com/office/drawing/2014/main" id="{1CC01435-1B59-49EE-93F6-F68FC6528489}"/>
               </a:ext>
             </a:extLst>
           </p:cNvPr>
@@ -6826,7 +6859,7 @@
           <p:cNvPr id="18" name="">
             <a:extLst xmlns:a="http://schemas.openxmlformats.org/drawingml/2006/main">
               <a:ext uri="{FF2B5EF4-FFF2-40B4-BE49-F238E27FC236}">
-                <a16:creationId xmlns:a16="http://schemas.microsoft.com/office/drawing/2014/main" id="{7D49B273-BD15-40B6-8A8F-FDD7BB473EEF}"/>
+                <a16:creationId xmlns:a16="http://schemas.microsoft.com/office/drawing/2014/main" id="{F17F6E06-1FCA-4087-A109-FB4448296723}"/>
               </a:ext>
             </a:extLst>
           </p:cNvPr>
@@ -6899,7 +6932,7 @@
           <p:cNvPr id="19" name="">
             <a:extLst xmlns:a="http://schemas.openxmlformats.org/drawingml/2006/main">
               <a:ext uri="{FF2B5EF4-FFF2-40B4-BE49-F238E27FC236}">
-                <a16:creationId xmlns:a16="http://schemas.microsoft.com/office/drawing/2014/main" id="{31510538-A0B5-4E52-9FCE-CC7C37E2E6F5}"/>
+                <a16:creationId xmlns:a16="http://schemas.microsoft.com/office/drawing/2014/main" id="{9B6B105C-F687-4680-9057-1392CDDB161F}"/>
               </a:ext>
             </a:extLst>
           </p:cNvPr>
@@ -6932,7 +6965,7 @@
           <p:cNvPr id="20" name="">
             <a:extLst xmlns:a="http://schemas.openxmlformats.org/drawingml/2006/main">
               <a:ext uri="{FF2B5EF4-FFF2-40B4-BE49-F238E27FC236}">
-                <a16:creationId xmlns:a16="http://schemas.microsoft.com/office/drawing/2014/main" id="{C5D1C898-1EAB-4E27-9546-DD47D275DB02}"/>
+                <a16:creationId xmlns:a16="http://schemas.microsoft.com/office/drawing/2014/main" id="{FB572A1C-9A34-411D-B6D3-D1FC76203011}"/>
               </a:ext>
             </a:extLst>
           </p:cNvPr>
@@ -6999,19 +7032,19 @@
           <p:cNvPr id="21" name="">
             <a:extLst xmlns:a="http://schemas.openxmlformats.org/drawingml/2006/main">
               <a:ext uri="{FF2B5EF4-FFF2-40B4-BE49-F238E27FC236}">
-                <a16:creationId xmlns:a16="http://schemas.microsoft.com/office/drawing/2014/main" id="{EA6D4A8E-3B2B-4B7A-A23B-F7BB28F19A63}"/>
-              </a:ext>
-            </a:extLst>
-          </p:cNvPr>
-          <p:cNvSpPr>
-            <a:spLocks xmlns:a="http://schemas.openxmlformats.org/drawingml/2006/main" noGrp="1"/>
-          </p:cNvSpPr>
-          <p:nvPr/>
-        </p:nvSpPr>
-        <p:spPr>
-          <a:xfrm xmlns:a="http://schemas.openxmlformats.org/drawingml/2006/main">
-            <a:off x="7524750" y="6524625"/>
-            <a:ext cx="3981450" cy="171450"/>
+                <a16:creationId xmlns:a16="http://schemas.microsoft.com/office/drawing/2014/main" id="{A5796AC3-9D56-4448-80E2-AFB965EE4A73}"/>
+              </a:ext>
+            </a:extLst>
+          </p:cNvPr>
+          <p:cNvSpPr>
+            <a:spLocks xmlns:a="http://schemas.openxmlformats.org/drawingml/2006/main" noGrp="1"/>
+          </p:cNvSpPr>
+          <p:nvPr/>
+        </p:nvSpPr>
+        <p:spPr>
+          <a:xfrm xmlns:a="http://schemas.openxmlformats.org/drawingml/2006/main">
+            <a:off x="7143750" y="6524625"/>
+            <a:ext cx="4362450" cy="171450"/>
           </a:xfrm>
           <a:prstGeom xmlns:a="http://schemas.openxmlformats.org/drawingml/2006/main" prst="rect">
             <a:avLst/>
@@ -7056,7 +7089,7 @@
                 <a:ea typeface="Arial"/>
                 <a:cs typeface="Arial"/>
               </a:rPr>
-              <a:t>Python  |  SQL  |  DuckDB  |  Streamlit</a:t>
+              <a:t>DuckDB  |  FastAPI  |  RabbitMQ  |  Streamlit</a:t>
             </a:r>
           </a:p>
         </p:txBody>
@@ -7064,7 +7097,7 @@
     </p:spTree>
     <p:extLst>
       <p:ext uri="{BB962C8B-B14F-4D97-AF65-F5344CB8AC3E}">
-        <p14:creationId xmlns:p14="http://schemas.microsoft.com/office/powerpoint/2010/main" val="874306021"/>
+        <p14:creationId xmlns:p14="http://schemas.microsoft.com/office/powerpoint/2010/main" val="951720566"/>
       </p:ext>
     </p:extLst>
   </p:cSld>
@@ -7095,7 +7128,7 @@
           <p:cNvPr id="32" name="">
             <a:extLst xmlns:a="http://schemas.openxmlformats.org/drawingml/2006/main">
               <a:ext uri="{FF2B5EF4-FFF2-40B4-BE49-F238E27FC236}">
-                <a16:creationId xmlns:a16="http://schemas.microsoft.com/office/drawing/2014/main" id="{F9D7E524-A8CD-49AC-8A2B-40F8F1D2EA72}"/>
+                <a16:creationId xmlns:a16="http://schemas.microsoft.com/office/drawing/2014/main" id="{449E894A-BA3D-4E1A-9353-4E23DD2AC68A}"/>
               </a:ext>
             </a:extLst>
           </p:cNvPr>
@@ -7162,7 +7195,7 @@
           <p:cNvPr id="2" name="">
             <a:extLst xmlns:a="http://schemas.openxmlformats.org/drawingml/2006/main">
               <a:ext uri="{FF2B5EF4-FFF2-40B4-BE49-F238E27FC236}">
-                <a16:creationId xmlns:a16="http://schemas.microsoft.com/office/drawing/2014/main" id="{49F5A87B-805C-43C3-89DE-503ABDA208A7}"/>
+                <a16:creationId xmlns:a16="http://schemas.microsoft.com/office/drawing/2014/main" id="{06CAC7A7-4A79-4732-8EF8-AB912D63C63E}"/>
               </a:ext>
             </a:extLst>
           </p:cNvPr>
@@ -7229,7 +7262,7 @@
           <p:cNvPr id="3" name="">
             <a:extLst xmlns:a="http://schemas.openxmlformats.org/drawingml/2006/main">
               <a:ext uri="{FF2B5EF4-FFF2-40B4-BE49-F238E27FC236}">
-                <a16:creationId xmlns:a16="http://schemas.microsoft.com/office/drawing/2014/main" id="{30D5E516-A199-45FA-B6A6-5B64EA85B1B4}"/>
+                <a16:creationId xmlns:a16="http://schemas.microsoft.com/office/drawing/2014/main" id="{6177E9D9-9D5E-478C-90D5-62B1314CDC50}"/>
               </a:ext>
             </a:extLst>
           </p:cNvPr>
@@ -7296,7 +7329,7 @@
           <p:cNvPr id="4" name="">
             <a:extLst xmlns:a="http://schemas.openxmlformats.org/drawingml/2006/main">
               <a:ext uri="{FF2B5EF4-FFF2-40B4-BE49-F238E27FC236}">
-                <a16:creationId xmlns:a16="http://schemas.microsoft.com/office/drawing/2014/main" id="{E73640C0-DAE5-4EDE-91C8-96393D30C92F}"/>
+                <a16:creationId xmlns:a16="http://schemas.microsoft.com/office/drawing/2014/main" id="{A7D68D93-8ECB-441F-ADCD-122F0A0FF1D5}"/>
               </a:ext>
             </a:extLst>
           </p:cNvPr>
@@ -7331,7 +7364,7 @@
           <p:cNvPr id="5" name="">
             <a:extLst xmlns:a="http://schemas.openxmlformats.org/drawingml/2006/main">
               <a:ext uri="{FF2B5EF4-FFF2-40B4-BE49-F238E27FC236}">
-                <a16:creationId xmlns:a16="http://schemas.microsoft.com/office/drawing/2014/main" id="{5C0230AF-0596-42D0-ACE3-02B31FF7A3E8}"/>
+                <a16:creationId xmlns:a16="http://schemas.microsoft.com/office/drawing/2014/main" id="{41E2BA3C-C06C-4E57-A35E-17FF2C08F23E}"/>
               </a:ext>
             </a:extLst>
           </p:cNvPr>
@@ -7398,7 +7431,7 @@
           <p:cNvPr id="6" name="">
             <a:extLst xmlns:a="http://schemas.openxmlformats.org/drawingml/2006/main">
               <a:ext uri="{FF2B5EF4-FFF2-40B4-BE49-F238E27FC236}">
-                <a16:creationId xmlns:a16="http://schemas.microsoft.com/office/drawing/2014/main" id="{69FFBABF-F3FE-42F3-9992-19FF0B620B20}"/>
+                <a16:creationId xmlns:a16="http://schemas.microsoft.com/office/drawing/2014/main" id="{EBE8D9A9-C5DD-4744-8B7C-C6EB7B81AC21}"/>
               </a:ext>
             </a:extLst>
           </p:cNvPr>
@@ -7478,7 +7511,30 @@
                 <a:ea typeface="Arial"/>
                 <a:cs typeface="Arial"/>
               </a:rPr>
-              <a:t>DummyJSON API</a:t>
+              <a:t>API snapshots</a:t>
+            </a:r>
+          </a:p>
+          <a:p xmlns:a="http://schemas.openxmlformats.org/drawingml/2006/main">
+            <a:pPr algn="ctr">
+              <a:defRPr sz="1350" b="0">
+                <a:solidFill>
+                  <a:srgbClr val="1B2430"/>
+                </a:solidFill>
+                <a:latin typeface="Arial"/>
+                <a:ea typeface="Arial"/>
+                <a:cs typeface="Arial"/>
+              </a:defRPr>
+            </a:pPr>
+            <a:r>
+              <a:rPr sz="1350" b="0">
+                <a:solidFill>
+                  <a:srgbClr val="1B2430"/>
+                </a:solidFill>
+                <a:latin typeface="Arial"/>
+                <a:ea typeface="Arial"/>
+                <a:cs typeface="Arial"/>
+              </a:rPr>
+              <a:t>live orders</a:t>
             </a:r>
           </a:p>
         </p:txBody>
@@ -7488,7 +7544,7 @@
           <p:cNvPr id="7" name="">
             <a:extLst xmlns:a="http://schemas.openxmlformats.org/drawingml/2006/main">
               <a:ext uri="{FF2B5EF4-FFF2-40B4-BE49-F238E27FC236}">
-                <a16:creationId xmlns:a16="http://schemas.microsoft.com/office/drawing/2014/main" id="{21DC1D93-FE54-4BC7-A0F9-81B1F17BBE58}"/>
+                <a16:creationId xmlns:a16="http://schemas.microsoft.com/office/drawing/2014/main" id="{B1D6DE24-5098-4A30-B965-0AE05626EEB4}"/>
               </a:ext>
             </a:extLst>
           </p:cNvPr>
@@ -7521,7 +7577,7 @@
           <p:cNvPr id="8" name="">
             <a:extLst xmlns:a="http://schemas.openxmlformats.org/drawingml/2006/main">
               <a:ext uri="{FF2B5EF4-FFF2-40B4-BE49-F238E27FC236}">
-                <a16:creationId xmlns:a16="http://schemas.microsoft.com/office/drawing/2014/main" id="{F3BDF25B-AAC5-4EA2-88B9-CAB6760CEAEC}"/>
+                <a16:creationId xmlns:a16="http://schemas.microsoft.com/office/drawing/2014/main" id="{5C0AF512-8243-4F2E-9414-96EEA83866EE}"/>
               </a:ext>
             </a:extLst>
           </p:cNvPr>
@@ -7556,7 +7612,7 @@
           <p:cNvPr id="9" name="">
             <a:extLst xmlns:a="http://schemas.openxmlformats.org/drawingml/2006/main">
               <a:ext uri="{FF2B5EF4-FFF2-40B4-BE49-F238E27FC236}">
-                <a16:creationId xmlns:a16="http://schemas.microsoft.com/office/drawing/2014/main" id="{5A07FAA4-B92F-4D5E-99AC-387792980744}"/>
+                <a16:creationId xmlns:a16="http://schemas.microsoft.com/office/drawing/2014/main" id="{93A71CA6-C120-462C-B5B7-3ABB45FF18A5}"/>
               </a:ext>
             </a:extLst>
           </p:cNvPr>
@@ -7613,7 +7669,7 @@
                 <a:ea typeface="Arial"/>
                 <a:cs typeface="Arial"/>
               </a:rPr>
-              <a:t>Extract</a:t>
+              <a:t>Capture</a:t>
             </a:r>
           </a:p>
         </p:txBody>
@@ -7623,7 +7679,7 @@
           <p:cNvPr id="10" name="">
             <a:extLst xmlns:a="http://schemas.openxmlformats.org/drawingml/2006/main">
               <a:ext uri="{FF2B5EF4-FFF2-40B4-BE49-F238E27FC236}">
-                <a16:creationId xmlns:a16="http://schemas.microsoft.com/office/drawing/2014/main" id="{62EAFB4E-A3CC-4360-89A9-27673A40EF9F}"/>
+                <a16:creationId xmlns:a16="http://schemas.microsoft.com/office/drawing/2014/main" id="{5DE5BA83-5F78-4E60-A612-B2F0EC829CD1}"/>
               </a:ext>
             </a:extLst>
           </p:cNvPr>
@@ -7680,7 +7736,7 @@
                 <a:ea typeface="Arial"/>
                 <a:cs typeface="Arial"/>
               </a:rPr>
-              <a:t>read_csv</a:t>
+              <a:t>Python ETL</a:t>
             </a:r>
           </a:p>
           <a:p xmlns:a="http://schemas.openxmlformats.org/drawingml/2006/main">
@@ -7703,7 +7759,7 @@
                 <a:ea typeface="Arial"/>
                 <a:cs typeface="Arial"/>
               </a:rPr>
-              <a:t>raw JSON snapshot</a:t>
+              <a:t>FastAPI validation</a:t>
             </a:r>
           </a:p>
         </p:txBody>
@@ -7713,7 +7769,7 @@
           <p:cNvPr id="11" name="">
             <a:extLst xmlns:a="http://schemas.openxmlformats.org/drawingml/2006/main">
               <a:ext uri="{FF2B5EF4-FFF2-40B4-BE49-F238E27FC236}">
-                <a16:creationId xmlns:a16="http://schemas.microsoft.com/office/drawing/2014/main" id="{76281ECA-7146-409E-BF2B-0E30BFC8FF03}"/>
+                <a16:creationId xmlns:a16="http://schemas.microsoft.com/office/drawing/2014/main" id="{4D036496-AD98-429A-A3A8-7D69D8A2443D}"/>
               </a:ext>
             </a:extLst>
           </p:cNvPr>
@@ -7746,7 +7802,7 @@
           <p:cNvPr id="12" name="">
             <a:extLst xmlns:a="http://schemas.openxmlformats.org/drawingml/2006/main">
               <a:ext uri="{FF2B5EF4-FFF2-40B4-BE49-F238E27FC236}">
-                <a16:creationId xmlns:a16="http://schemas.microsoft.com/office/drawing/2014/main" id="{363D5192-9733-41A5-8675-0B04DA93A83B}"/>
+                <a16:creationId xmlns:a16="http://schemas.microsoft.com/office/drawing/2014/main" id="{FC36CCAD-2A3F-4229-A305-06FA16B669CA}"/>
               </a:ext>
             </a:extLst>
           </p:cNvPr>
@@ -7781,7 +7837,7 @@
           <p:cNvPr id="13" name="">
             <a:extLst xmlns:a="http://schemas.openxmlformats.org/drawingml/2006/main">
               <a:ext uri="{FF2B5EF4-FFF2-40B4-BE49-F238E27FC236}">
-                <a16:creationId xmlns:a16="http://schemas.microsoft.com/office/drawing/2014/main" id="{B54B0608-5E05-40B4-96F8-CB462414C31D}"/>
+                <a16:creationId xmlns:a16="http://schemas.microsoft.com/office/drawing/2014/main" id="{EAE5B098-E77D-4B64-B13D-95E22EFA0710}"/>
               </a:ext>
             </a:extLst>
           </p:cNvPr>
@@ -7838,7 +7894,7 @@
                 <a:ea typeface="Arial"/>
                 <a:cs typeface="Arial"/>
               </a:rPr>
-              <a:t>Transform</a:t>
+              <a:t>Transport</a:t>
             </a:r>
           </a:p>
         </p:txBody>
@@ -7848,7 +7904,7 @@
           <p:cNvPr id="14" name="">
             <a:extLst xmlns:a="http://schemas.openxmlformats.org/drawingml/2006/main">
               <a:ext uri="{FF2B5EF4-FFF2-40B4-BE49-F238E27FC236}">
-                <a16:creationId xmlns:a16="http://schemas.microsoft.com/office/drawing/2014/main" id="{ED6E0E22-6293-4F0D-AAD6-1359CF43EED6}"/>
+                <a16:creationId xmlns:a16="http://schemas.microsoft.com/office/drawing/2014/main" id="{8CD33742-DF5C-4E0F-ACD2-AB4397075173}"/>
               </a:ext>
             </a:extLst>
           </p:cNvPr>
@@ -7905,7 +7961,7 @@
                 <a:ea typeface="Arial"/>
                 <a:cs typeface="Arial"/>
               </a:rPr>
-              <a:t>TRY_CAST</a:t>
+              <a:t>RabbitMQ</a:t>
             </a:r>
           </a:p>
           <a:p xmlns:a="http://schemas.openxmlformats.org/drawingml/2006/main">
@@ -7928,7 +7984,7 @@
                 <a:ea typeface="Arial"/>
                 <a:cs typeface="Arial"/>
               </a:rPr>
-              <a:t>deduplicate</a:t>
+              <a:t>durable queue</a:t>
             </a:r>
           </a:p>
           <a:p xmlns:a="http://schemas.openxmlformats.org/drawingml/2006/main">
@@ -7951,7 +8007,7 @@
                 <a:ea typeface="Arial"/>
                 <a:cs typeface="Arial"/>
               </a:rPr>
-              <a:t>validate</a:t>
+              <a:t>manual ack</a:t>
             </a:r>
           </a:p>
         </p:txBody>
@@ -7961,7 +8017,7 @@
           <p:cNvPr id="15" name="">
             <a:extLst xmlns:a="http://schemas.openxmlformats.org/drawingml/2006/main">
               <a:ext uri="{FF2B5EF4-FFF2-40B4-BE49-F238E27FC236}">
-                <a16:creationId xmlns:a16="http://schemas.microsoft.com/office/drawing/2014/main" id="{B0781BE6-DF41-4649-BC10-F20AA8C68069}"/>
+                <a16:creationId xmlns:a16="http://schemas.microsoft.com/office/drawing/2014/main" id="{F7DC439E-EFAA-4CD2-8009-252AA2B5AF35}"/>
               </a:ext>
             </a:extLst>
           </p:cNvPr>
@@ -7994,7 +8050,7 @@
           <p:cNvPr id="16" name="">
             <a:extLst xmlns:a="http://schemas.openxmlformats.org/drawingml/2006/main">
               <a:ext uri="{FF2B5EF4-FFF2-40B4-BE49-F238E27FC236}">
-                <a16:creationId xmlns:a16="http://schemas.microsoft.com/office/drawing/2014/main" id="{4F8F50F6-B322-421E-BAF5-F574ED7D85A0}"/>
+                <a16:creationId xmlns:a16="http://schemas.microsoft.com/office/drawing/2014/main" id="{26FB6017-FDA9-418A-856A-82DC61B69F95}"/>
               </a:ext>
             </a:extLst>
           </p:cNvPr>
@@ -8029,7 +8085,7 @@
           <p:cNvPr id="17" name="">
             <a:extLst xmlns:a="http://schemas.openxmlformats.org/drawingml/2006/main">
               <a:ext uri="{FF2B5EF4-FFF2-40B4-BE49-F238E27FC236}">
-                <a16:creationId xmlns:a16="http://schemas.microsoft.com/office/drawing/2014/main" id="{07A4F075-107D-4D8A-8F7A-D2E82BA50269}"/>
+                <a16:creationId xmlns:a16="http://schemas.microsoft.com/office/drawing/2014/main" id="{CEA2D9FC-1C57-43B2-972C-4EDF2EF9ED5B}"/>
               </a:ext>
             </a:extLst>
           </p:cNvPr>
@@ -8086,7 +8142,7 @@
                 <a:ea typeface="Arial"/>
                 <a:cs typeface="Arial"/>
               </a:rPr>
-              <a:t>Warehouse</a:t>
+              <a:t>Model</a:t>
             </a:r>
           </a:p>
         </p:txBody>
@@ -8096,7 +8152,7 @@
           <p:cNvPr id="18" name="">
             <a:extLst xmlns:a="http://schemas.openxmlformats.org/drawingml/2006/main">
               <a:ext uri="{FF2B5EF4-FFF2-40B4-BE49-F238E27FC236}">
-                <a16:creationId xmlns:a16="http://schemas.microsoft.com/office/drawing/2014/main" id="{162C5F87-DBDC-4567-9D7A-234D088CF0FD}"/>
+                <a16:creationId xmlns:a16="http://schemas.microsoft.com/office/drawing/2014/main" id="{C4B4C0DA-CFCF-4278-BEB5-DAE9290C1153}"/>
               </a:ext>
             </a:extLst>
           </p:cNvPr>
@@ -8153,7 +8209,7 @@
                 <a:ea typeface="Arial"/>
                 <a:cs typeface="Arial"/>
               </a:rPr>
-              <a:t>fact_sales</a:t>
+              <a:t>DuckDB star schema</a:t>
             </a:r>
           </a:p>
           <a:p xmlns:a="http://schemas.openxmlformats.org/drawingml/2006/main">
@@ -8176,7 +8232,7 @@
                 <a:ea typeface="Arial"/>
                 <a:cs typeface="Arial"/>
               </a:rPr>
-              <a:t>3 dimensions</a:t>
+              <a:t>stream staging</a:t>
             </a:r>
           </a:p>
           <a:p xmlns:a="http://schemas.openxmlformats.org/drawingml/2006/main">
@@ -8209,7 +8265,7 @@
           <p:cNvPr id="19" name="">
             <a:extLst xmlns:a="http://schemas.openxmlformats.org/drawingml/2006/main">
               <a:ext uri="{FF2B5EF4-FFF2-40B4-BE49-F238E27FC236}">
-                <a16:creationId xmlns:a16="http://schemas.microsoft.com/office/drawing/2014/main" id="{6EDC1712-44CD-4337-A302-92EA896F42A1}"/>
+                <a16:creationId xmlns:a16="http://schemas.microsoft.com/office/drawing/2014/main" id="{28965F68-3099-4C18-806D-8FA0455DB462}"/>
               </a:ext>
             </a:extLst>
           </p:cNvPr>
@@ -8242,7 +8298,7 @@
           <p:cNvPr id="20" name="">
             <a:extLst xmlns:a="http://schemas.openxmlformats.org/drawingml/2006/main">
               <a:ext uri="{FF2B5EF4-FFF2-40B4-BE49-F238E27FC236}">
-                <a16:creationId xmlns:a16="http://schemas.microsoft.com/office/drawing/2014/main" id="{08683B89-10E6-40C9-92AA-554B6A7DC808}"/>
+                <a16:creationId xmlns:a16="http://schemas.microsoft.com/office/drawing/2014/main" id="{04990C3B-CA75-4AFB-ACC7-F89515F1F6D1}"/>
               </a:ext>
             </a:extLst>
           </p:cNvPr>
@@ -8277,7 +8333,7 @@
           <p:cNvPr id="21" name="">
             <a:extLst xmlns:a="http://schemas.openxmlformats.org/drawingml/2006/main">
               <a:ext uri="{FF2B5EF4-FFF2-40B4-BE49-F238E27FC236}">
-                <a16:creationId xmlns:a16="http://schemas.microsoft.com/office/drawing/2014/main" id="{0D0B38EF-CA2A-4C18-8FAD-9533AE4EB4F0}"/>
+                <a16:creationId xmlns:a16="http://schemas.microsoft.com/office/drawing/2014/main" id="{A092CD8C-0DF3-460F-99EF-F587CE9E4015}"/>
               </a:ext>
             </a:extLst>
           </p:cNvPr>
@@ -8344,7 +8400,7 @@
           <p:cNvPr id="22" name="">
             <a:extLst xmlns:a="http://schemas.openxmlformats.org/drawingml/2006/main">
               <a:ext uri="{FF2B5EF4-FFF2-40B4-BE49-F238E27FC236}">
-                <a16:creationId xmlns:a16="http://schemas.microsoft.com/office/drawing/2014/main" id="{5AA28EA4-4264-4EB4-BE41-EB39CB514EF4}"/>
+                <a16:creationId xmlns:a16="http://schemas.microsoft.com/office/drawing/2014/main" id="{BF98FA7B-3814-4B2E-850E-3E9DB82D3C25}"/>
               </a:ext>
             </a:extLst>
           </p:cNvPr>
@@ -8457,7 +8513,7 @@
           <p:cNvPr id="23" name="">
             <a:extLst xmlns:a="http://schemas.openxmlformats.org/drawingml/2006/main">
               <a:ext uri="{FF2B5EF4-FFF2-40B4-BE49-F238E27FC236}">
-                <a16:creationId xmlns:a16="http://schemas.microsoft.com/office/drawing/2014/main" id="{F3EEC668-906A-4F21-8AFE-B3B73360DFCB}"/>
+                <a16:creationId xmlns:a16="http://schemas.microsoft.com/office/drawing/2014/main" id="{8447D273-CF1D-469E-871F-A5A4C1555F3E}"/>
               </a:ext>
             </a:extLst>
           </p:cNvPr>
@@ -8524,7 +8580,7 @@
           <p:cNvPr id="24" name="">
             <a:extLst xmlns:a="http://schemas.openxmlformats.org/drawingml/2006/main">
               <a:ext uri="{FF2B5EF4-FFF2-40B4-BE49-F238E27FC236}">
-                <a16:creationId xmlns:a16="http://schemas.microsoft.com/office/drawing/2014/main" id="{31A8973D-6CBA-4C6A-87FC-E2FE0EF3DED6}"/>
+                <a16:creationId xmlns:a16="http://schemas.microsoft.com/office/drawing/2014/main" id="{E81F59DD-1F0D-4963-9FBC-B4BD9EBCDFFE}"/>
               </a:ext>
             </a:extLst>
           </p:cNvPr>
@@ -8591,7 +8647,7 @@
           <p:cNvPr id="25" name="">
             <a:extLst xmlns:a="http://schemas.openxmlformats.org/drawingml/2006/main">
               <a:ext uri="{FF2B5EF4-FFF2-40B4-BE49-F238E27FC236}">
-                <a16:creationId xmlns:a16="http://schemas.microsoft.com/office/drawing/2014/main" id="{D1ABD5DE-0353-46E9-B35C-1971A2362237}"/>
+                <a16:creationId xmlns:a16="http://schemas.microsoft.com/office/drawing/2014/main" id="{DBB5B48C-927E-4606-8598-EBCC1090B332}"/>
               </a:ext>
             </a:extLst>
           </p:cNvPr>
@@ -8658,7 +8714,7 @@
           <p:cNvPr id="26" name="">
             <a:extLst xmlns:a="http://schemas.openxmlformats.org/drawingml/2006/main">
               <a:ext uri="{FF2B5EF4-FFF2-40B4-BE49-F238E27FC236}">
-                <a16:creationId xmlns:a16="http://schemas.microsoft.com/office/drawing/2014/main" id="{893C802F-2EB1-44D3-AFAA-3228FCCB197B}"/>
+                <a16:creationId xmlns:a16="http://schemas.microsoft.com/office/drawing/2014/main" id="{3D02BCE9-20C5-4FE4-9C92-A597D780D06E}"/>
               </a:ext>
             </a:extLst>
           </p:cNvPr>
@@ -8725,7 +8781,7 @@
           <p:cNvPr id="27" name="">
             <a:extLst xmlns:a="http://schemas.openxmlformats.org/drawingml/2006/main">
               <a:ext uri="{FF2B5EF4-FFF2-40B4-BE49-F238E27FC236}">
-                <a16:creationId xmlns:a16="http://schemas.microsoft.com/office/drawing/2014/main" id="{AB4B0762-2732-4BBA-8744-4070B2F6EAFE}"/>
+                <a16:creationId xmlns:a16="http://schemas.microsoft.com/office/drawing/2014/main" id="{D422936B-C316-43C9-980F-3852ACC3F3D0}"/>
               </a:ext>
             </a:extLst>
           </p:cNvPr>
@@ -8792,19 +8848,19 @@
           <p:cNvPr id="28" name="">
             <a:extLst xmlns:a="http://schemas.openxmlformats.org/drawingml/2006/main">
               <a:ext uri="{FF2B5EF4-FFF2-40B4-BE49-F238E27FC236}">
-                <a16:creationId xmlns:a16="http://schemas.microsoft.com/office/drawing/2014/main" id="{2F9F9CCC-2CE8-4699-81B5-2D032D36DD7A}"/>
-              </a:ext>
-            </a:extLst>
-          </p:cNvPr>
-          <p:cNvSpPr>
-            <a:spLocks xmlns:a="http://schemas.openxmlformats.org/drawingml/2006/main" noGrp="1"/>
-          </p:cNvSpPr>
-          <p:nvPr/>
-        </p:nvSpPr>
-        <p:spPr>
-          <a:xfrm xmlns:a="http://schemas.openxmlformats.org/drawingml/2006/main">
-            <a:off x="9810750" y="4953000"/>
-            <a:ext cx="1619250" cy="266700"/>
+                <a16:creationId xmlns:a16="http://schemas.microsoft.com/office/drawing/2014/main" id="{13B3C52F-DB54-457E-8287-554E795EE176}"/>
+              </a:ext>
+            </a:extLst>
+          </p:cNvPr>
+          <p:cNvSpPr>
+            <a:spLocks xmlns:a="http://schemas.openxmlformats.org/drawingml/2006/main" noGrp="1"/>
+          </p:cNvSpPr>
+          <p:nvPr/>
+        </p:nvSpPr>
+        <p:spPr>
+          <a:xfrm xmlns:a="http://schemas.openxmlformats.org/drawingml/2006/main">
+            <a:off x="9696450" y="4953000"/>
+            <a:ext cx="1733550" cy="266700"/>
           </a:xfrm>
           <a:prstGeom xmlns:a="http://schemas.openxmlformats.org/drawingml/2006/main" prst="rect">
             <a:avLst/>
@@ -8849,7 +8905,7 @@
                 <a:ea typeface="Arial"/>
                 <a:cs typeface="Arial"/>
               </a:rPr>
-              <a:t>API metadata</a:t>
+              <a:t>stream validation</a:t>
             </a:r>
           </a:p>
         </p:txBody>
@@ -8859,7 +8915,7 @@
           <p:cNvPr id="29" name="">
             <a:extLst xmlns:a="http://schemas.openxmlformats.org/drawingml/2006/main">
               <a:ext uri="{FF2B5EF4-FFF2-40B4-BE49-F238E27FC236}">
-                <a16:creationId xmlns:a16="http://schemas.microsoft.com/office/drawing/2014/main" id="{5B45DFA5-5A78-4D04-AC9A-457AB289BA9C}"/>
+                <a16:creationId xmlns:a16="http://schemas.microsoft.com/office/drawing/2014/main" id="{5FDBEDF8-AEA0-4147-8E67-493E823E543D}"/>
               </a:ext>
             </a:extLst>
           </p:cNvPr>
@@ -8892,7 +8948,7 @@
           <p:cNvPr id="30" name="">
             <a:extLst xmlns:a="http://schemas.openxmlformats.org/drawingml/2006/main">
               <a:ext uri="{FF2B5EF4-FFF2-40B4-BE49-F238E27FC236}">
-                <a16:creationId xmlns:a16="http://schemas.microsoft.com/office/drawing/2014/main" id="{3C6DDEB8-F9FC-4159-BB44-6E2C4F431A70}"/>
+                <a16:creationId xmlns:a16="http://schemas.microsoft.com/office/drawing/2014/main" id="{C9FF781B-7C22-4FD7-821C-AC3EBF11177B}"/>
               </a:ext>
             </a:extLst>
           </p:cNvPr>
@@ -8959,19 +9015,19 @@
           <p:cNvPr id="31" name="">
             <a:extLst xmlns:a="http://schemas.openxmlformats.org/drawingml/2006/main">
               <a:ext uri="{FF2B5EF4-FFF2-40B4-BE49-F238E27FC236}">
-                <a16:creationId xmlns:a16="http://schemas.microsoft.com/office/drawing/2014/main" id="{CA7C2939-335F-4494-A672-4DA26458B6A1}"/>
-              </a:ext>
-            </a:extLst>
-          </p:cNvPr>
-          <p:cNvSpPr>
-            <a:spLocks xmlns:a="http://schemas.openxmlformats.org/drawingml/2006/main" noGrp="1"/>
-          </p:cNvSpPr>
-          <p:nvPr/>
-        </p:nvSpPr>
-        <p:spPr>
-          <a:xfrm xmlns:a="http://schemas.openxmlformats.org/drawingml/2006/main">
-            <a:off x="7524750" y="6524625"/>
-            <a:ext cx="3981450" cy="171450"/>
+                <a16:creationId xmlns:a16="http://schemas.microsoft.com/office/drawing/2014/main" id="{993F8E9D-869B-4379-88D9-847042F9D413}"/>
+              </a:ext>
+            </a:extLst>
+          </p:cNvPr>
+          <p:cNvSpPr>
+            <a:spLocks xmlns:a="http://schemas.openxmlformats.org/drawingml/2006/main" noGrp="1"/>
+          </p:cNvSpPr>
+          <p:nvPr/>
+        </p:nvSpPr>
+        <p:spPr>
+          <a:xfrm xmlns:a="http://schemas.openxmlformats.org/drawingml/2006/main">
+            <a:off x="7143750" y="6524625"/>
+            <a:ext cx="4362450" cy="171450"/>
           </a:xfrm>
           <a:prstGeom xmlns:a="http://schemas.openxmlformats.org/drawingml/2006/main" prst="rect">
             <a:avLst/>
@@ -9016,7 +9072,7 @@
                 <a:ea typeface="Arial"/>
                 <a:cs typeface="Arial"/>
               </a:rPr>
-              <a:t>Python  |  SQL  |  DuckDB  |  Streamlit</a:t>
+              <a:t>DuckDB  |  FastAPI  |  RabbitMQ  |  Streamlit</a:t>
             </a:r>
           </a:p>
         </p:txBody>
@@ -9024,7 +9080,7 @@
     </p:spTree>
     <p:extLst>
       <p:ext uri="{BB962C8B-B14F-4D97-AF65-F5344CB8AC3E}">
-        <p14:creationId xmlns:p14="http://schemas.microsoft.com/office/powerpoint/2010/main" val="1765294803"/>
+        <p14:creationId xmlns:p14="http://schemas.microsoft.com/office/powerpoint/2010/main" val="2125886001"/>
       </p:ext>
     </p:extLst>
   </p:cSld>
@@ -9055,7 +9111,7 @@
           <p:cNvPr id="28" name="">
             <a:extLst xmlns:a="http://schemas.openxmlformats.org/drawingml/2006/main">
               <a:ext uri="{FF2B5EF4-FFF2-40B4-BE49-F238E27FC236}">
-                <a16:creationId xmlns:a16="http://schemas.microsoft.com/office/drawing/2014/main" id="{E325388A-A1DE-43B8-BAC7-3BE542A497EA}"/>
+                <a16:creationId xmlns:a16="http://schemas.microsoft.com/office/drawing/2014/main" id="{24DA86B0-25BB-46B5-8960-172A69A2A785}"/>
               </a:ext>
             </a:extLst>
           </p:cNvPr>
@@ -9122,7 +9178,7 @@
           <p:cNvPr id="2" name="">
             <a:extLst xmlns:a="http://schemas.openxmlformats.org/drawingml/2006/main">
               <a:ext uri="{FF2B5EF4-FFF2-40B4-BE49-F238E27FC236}">
-                <a16:creationId xmlns:a16="http://schemas.microsoft.com/office/drawing/2014/main" id="{C609B6C5-9F6C-4854-96A6-3473D8F32123}"/>
+                <a16:creationId xmlns:a16="http://schemas.microsoft.com/office/drawing/2014/main" id="{54961C3A-DB5E-45BE-BFA5-201BC9AA5072}"/>
               </a:ext>
             </a:extLst>
           </p:cNvPr>
@@ -9189,7 +9245,7 @@
           <p:cNvPr id="3" name="">
             <a:extLst xmlns:a="http://schemas.openxmlformats.org/drawingml/2006/main">
               <a:ext uri="{FF2B5EF4-FFF2-40B4-BE49-F238E27FC236}">
-                <a16:creationId xmlns:a16="http://schemas.microsoft.com/office/drawing/2014/main" id="{BC8B6768-F25F-46C6-BD57-9F623038306F}"/>
+                <a16:creationId xmlns:a16="http://schemas.microsoft.com/office/drawing/2014/main" id="{C33B700A-5B6E-4080-ABAD-60C9E99CD48B}"/>
               </a:ext>
             </a:extLst>
           </p:cNvPr>
@@ -9256,7 +9312,7 @@
           <p:cNvPr id="4" name="">
             <a:extLst xmlns:a="http://schemas.openxmlformats.org/drawingml/2006/main">
               <a:ext uri="{FF2B5EF4-FFF2-40B4-BE49-F238E27FC236}">
-                <a16:creationId xmlns:a16="http://schemas.microsoft.com/office/drawing/2014/main" id="{06F2640D-D5FC-4E4A-904A-D858BC1C5689}"/>
+                <a16:creationId xmlns:a16="http://schemas.microsoft.com/office/drawing/2014/main" id="{710C639C-8542-4F55-A296-8774160C7D4A}"/>
               </a:ext>
             </a:extLst>
           </p:cNvPr>
@@ -9323,7 +9379,7 @@
           <p:cNvPr id="5" name="">
             <a:extLst xmlns:a="http://schemas.openxmlformats.org/drawingml/2006/main">
               <a:ext uri="{FF2B5EF4-FFF2-40B4-BE49-F238E27FC236}">
-                <a16:creationId xmlns:a16="http://schemas.microsoft.com/office/drawing/2014/main" id="{7A5C0CB7-C986-4EB8-9E88-036E5BC61B48}"/>
+                <a16:creationId xmlns:a16="http://schemas.microsoft.com/office/drawing/2014/main" id="{BD154850-5B03-43BE-8461-50A8F2443E74}"/>
               </a:ext>
             </a:extLst>
           </p:cNvPr>
@@ -9390,7 +9446,7 @@
           <p:cNvPr id="6" name="">
             <a:extLst xmlns:a="http://schemas.openxmlformats.org/drawingml/2006/main">
               <a:ext uri="{FF2B5EF4-FFF2-40B4-BE49-F238E27FC236}">
-                <a16:creationId xmlns:a16="http://schemas.microsoft.com/office/drawing/2014/main" id="{25B1B2E9-95FD-4AC3-AC8F-E654F31B9305}"/>
+                <a16:creationId xmlns:a16="http://schemas.microsoft.com/office/drawing/2014/main" id="{9341B435-4B45-47BA-AC75-7AA8821E011A}"/>
               </a:ext>
             </a:extLst>
           </p:cNvPr>
@@ -9457,7 +9513,7 @@
           <p:cNvPr id="7" name="">
             <a:extLst xmlns:a="http://schemas.openxmlformats.org/drawingml/2006/main">
               <a:ext uri="{FF2B5EF4-FFF2-40B4-BE49-F238E27FC236}">
-                <a16:creationId xmlns:a16="http://schemas.microsoft.com/office/drawing/2014/main" id="{03AC0FA0-715C-4246-AF3D-175338EBBA27}"/>
+                <a16:creationId xmlns:a16="http://schemas.microsoft.com/office/drawing/2014/main" id="{31AEB816-59DC-4CD1-A5B1-28E04D1D68DB}"/>
               </a:ext>
             </a:extLst>
           </p:cNvPr>
@@ -9524,7 +9580,7 @@
           <p:cNvPr id="8" name="">
             <a:extLst xmlns:a="http://schemas.openxmlformats.org/drawingml/2006/main">
               <a:ext uri="{FF2B5EF4-FFF2-40B4-BE49-F238E27FC236}">
-                <a16:creationId xmlns:a16="http://schemas.microsoft.com/office/drawing/2014/main" id="{2DAA77EA-83B5-43DF-9329-9D0C99373C94}"/>
+                <a16:creationId xmlns:a16="http://schemas.microsoft.com/office/drawing/2014/main" id="{3C12A756-C9BB-4516-B364-DFA944C859E3}"/>
               </a:ext>
             </a:extLst>
           </p:cNvPr>
@@ -9591,7 +9647,7 @@
           <p:cNvPr id="9" name="">
             <a:extLst xmlns:a="http://schemas.openxmlformats.org/drawingml/2006/main">
               <a:ext uri="{FF2B5EF4-FFF2-40B4-BE49-F238E27FC236}">
-                <a16:creationId xmlns:a16="http://schemas.microsoft.com/office/drawing/2014/main" id="{2F332B32-5D70-44F7-A74F-1EE34CF7B3EE}"/>
+                <a16:creationId xmlns:a16="http://schemas.microsoft.com/office/drawing/2014/main" id="{9D04B538-9155-42D8-A699-2327C1CACEE0}"/>
               </a:ext>
             </a:extLst>
           </p:cNvPr>
@@ -9658,7 +9714,7 @@
           <p:cNvPr id="10" name="">
             <a:extLst xmlns:a="http://schemas.openxmlformats.org/drawingml/2006/main">
               <a:ext uri="{FF2B5EF4-FFF2-40B4-BE49-F238E27FC236}">
-                <a16:creationId xmlns:a16="http://schemas.microsoft.com/office/drawing/2014/main" id="{EB1C0538-F3A3-4F78-8E59-CD005204A4A3}"/>
+                <a16:creationId xmlns:a16="http://schemas.microsoft.com/office/drawing/2014/main" id="{3624DE35-2A78-47F4-B5FE-7E1AF4534F91}"/>
               </a:ext>
             </a:extLst>
           </p:cNvPr>
@@ -9725,7 +9781,7 @@
           <p:cNvPr id="11" name="">
             <a:extLst xmlns:a="http://schemas.openxmlformats.org/drawingml/2006/main">
               <a:ext uri="{FF2B5EF4-FFF2-40B4-BE49-F238E27FC236}">
-                <a16:creationId xmlns:a16="http://schemas.microsoft.com/office/drawing/2014/main" id="{47476398-083B-460C-BAFD-A0B4CFF45448}"/>
+                <a16:creationId xmlns:a16="http://schemas.microsoft.com/office/drawing/2014/main" id="{2DF63FEC-4EC5-4B57-B0C7-7C96ABEBC682}"/>
               </a:ext>
             </a:extLst>
           </p:cNvPr>
@@ -9792,7 +9848,7 @@
           <p:cNvPr id="12" name="">
             <a:extLst xmlns:a="http://schemas.openxmlformats.org/drawingml/2006/main">
               <a:ext uri="{FF2B5EF4-FFF2-40B4-BE49-F238E27FC236}">
-                <a16:creationId xmlns:a16="http://schemas.microsoft.com/office/drawing/2014/main" id="{0366EBBF-2B49-41B9-839D-E926B85D4BAC}"/>
+                <a16:creationId xmlns:a16="http://schemas.microsoft.com/office/drawing/2014/main" id="{154970A2-4430-4254-9074-B0746FBD0B33}"/>
               </a:ext>
             </a:extLst>
           </p:cNvPr>
@@ -9827,7 +9883,7 @@
           <p:cNvPr id="13" name="">
             <a:extLst xmlns:a="http://schemas.openxmlformats.org/drawingml/2006/main">
               <a:ext uri="{FF2B5EF4-FFF2-40B4-BE49-F238E27FC236}">
-                <a16:creationId xmlns:a16="http://schemas.microsoft.com/office/drawing/2014/main" id="{5BF42FA1-D43D-4FA2-939F-50547A7FF6A5}"/>
+                <a16:creationId xmlns:a16="http://schemas.microsoft.com/office/drawing/2014/main" id="{AD1DD64E-57D8-48BF-AA60-015856DFFC22}"/>
               </a:ext>
             </a:extLst>
           </p:cNvPr>
@@ -9894,7 +9950,7 @@
           <p:cNvPr id="14" name="">
             <a:extLst xmlns:a="http://schemas.openxmlformats.org/drawingml/2006/main">
               <a:ext uri="{FF2B5EF4-FFF2-40B4-BE49-F238E27FC236}">
-                <a16:creationId xmlns:a16="http://schemas.microsoft.com/office/drawing/2014/main" id="{8C313832-7015-445F-845F-E38387D66E78}"/>
+                <a16:creationId xmlns:a16="http://schemas.microsoft.com/office/drawing/2014/main" id="{18FA5F49-A3C1-4BC3-9E2E-059A0CE55748}"/>
               </a:ext>
             </a:extLst>
           </p:cNvPr>
@@ -10053,7 +10109,7 @@
           <p:cNvPr id="15" name="">
             <a:extLst xmlns:a="http://schemas.openxmlformats.org/drawingml/2006/main">
               <a:ext uri="{FF2B5EF4-FFF2-40B4-BE49-F238E27FC236}">
-                <a16:creationId xmlns:a16="http://schemas.microsoft.com/office/drawing/2014/main" id="{C7262FC4-12D4-42BC-BC6F-4F68DEE0A628}"/>
+                <a16:creationId xmlns:a16="http://schemas.microsoft.com/office/drawing/2014/main" id="{3FA5CEB5-3857-4CB5-93F6-894D6C872D64}"/>
               </a:ext>
             </a:extLst>
           </p:cNvPr>
@@ -10088,7 +10144,7 @@
           <p:cNvPr id="16" name="">
             <a:extLst xmlns:a="http://schemas.openxmlformats.org/drawingml/2006/main">
               <a:ext uri="{FF2B5EF4-FFF2-40B4-BE49-F238E27FC236}">
-                <a16:creationId xmlns:a16="http://schemas.microsoft.com/office/drawing/2014/main" id="{5668EE36-047C-4443-8FF5-229E0A1D1D69}"/>
+                <a16:creationId xmlns:a16="http://schemas.microsoft.com/office/drawing/2014/main" id="{A6A2B517-C8E8-414A-8BFA-74B90ED61409}"/>
               </a:ext>
             </a:extLst>
           </p:cNvPr>
@@ -10155,7 +10211,7 @@
           <p:cNvPr id="17" name="">
             <a:extLst xmlns:a="http://schemas.openxmlformats.org/drawingml/2006/main">
               <a:ext uri="{FF2B5EF4-FFF2-40B4-BE49-F238E27FC236}">
-                <a16:creationId xmlns:a16="http://schemas.microsoft.com/office/drawing/2014/main" id="{97E82A0B-7899-440E-9138-7CFD2D10BE00}"/>
+                <a16:creationId xmlns:a16="http://schemas.microsoft.com/office/drawing/2014/main" id="{028492E2-3094-40F7-9A63-B9E46A4AA895}"/>
               </a:ext>
             </a:extLst>
           </p:cNvPr>
@@ -10245,7 +10301,7 @@
           <p:cNvPr id="18" name="">
             <a:extLst xmlns:a="http://schemas.openxmlformats.org/drawingml/2006/main">
               <a:ext uri="{FF2B5EF4-FFF2-40B4-BE49-F238E27FC236}">
-                <a16:creationId xmlns:a16="http://schemas.microsoft.com/office/drawing/2014/main" id="{FBFA5865-5074-4A7E-A93D-C2EB90E6ED85}"/>
+                <a16:creationId xmlns:a16="http://schemas.microsoft.com/office/drawing/2014/main" id="{17653D71-89BB-47DE-A071-72F48D8DAA3B}"/>
               </a:ext>
             </a:extLst>
           </p:cNvPr>
@@ -10280,7 +10336,7 @@
           <p:cNvPr id="19" name="">
             <a:extLst xmlns:a="http://schemas.openxmlformats.org/drawingml/2006/main">
               <a:ext uri="{FF2B5EF4-FFF2-40B4-BE49-F238E27FC236}">
-                <a16:creationId xmlns:a16="http://schemas.microsoft.com/office/drawing/2014/main" id="{796A53DF-09EC-4E1D-8D36-EE8E7D6B1811}"/>
+                <a16:creationId xmlns:a16="http://schemas.microsoft.com/office/drawing/2014/main" id="{98ABC462-6D13-441F-9328-00590859EF76}"/>
               </a:ext>
             </a:extLst>
           </p:cNvPr>
@@ -10347,7 +10403,7 @@
           <p:cNvPr id="20" name="">
             <a:extLst xmlns:a="http://schemas.openxmlformats.org/drawingml/2006/main">
               <a:ext uri="{FF2B5EF4-FFF2-40B4-BE49-F238E27FC236}">
-                <a16:creationId xmlns:a16="http://schemas.microsoft.com/office/drawing/2014/main" id="{7E1591D8-1854-4C62-ACF1-105251BF4F35}"/>
+                <a16:creationId xmlns:a16="http://schemas.microsoft.com/office/drawing/2014/main" id="{E44A824C-E363-4771-B510-59BBE60A774E}"/>
               </a:ext>
             </a:extLst>
           </p:cNvPr>
@@ -10437,7 +10493,7 @@
           <p:cNvPr id="21" name="">
             <a:extLst xmlns:a="http://schemas.openxmlformats.org/drawingml/2006/main">
               <a:ext uri="{FF2B5EF4-FFF2-40B4-BE49-F238E27FC236}">
-                <a16:creationId xmlns:a16="http://schemas.microsoft.com/office/drawing/2014/main" id="{105A7A57-C3FE-4121-9A41-CBA9496876A0}"/>
+                <a16:creationId xmlns:a16="http://schemas.microsoft.com/office/drawing/2014/main" id="{F4FFA045-6FAB-48A1-A5EF-7B5BFBC1AD6C}"/>
               </a:ext>
             </a:extLst>
           </p:cNvPr>
@@ -10472,7 +10528,7 @@
           <p:cNvPr id="22" name="">
             <a:extLst xmlns:a="http://schemas.openxmlformats.org/drawingml/2006/main">
               <a:ext uri="{FF2B5EF4-FFF2-40B4-BE49-F238E27FC236}">
-                <a16:creationId xmlns:a16="http://schemas.microsoft.com/office/drawing/2014/main" id="{6E7D4020-77DB-4EC5-A31F-35A6DE0A7373}"/>
+                <a16:creationId xmlns:a16="http://schemas.microsoft.com/office/drawing/2014/main" id="{7A728178-EFB5-419F-92E8-1979B99896B7}"/>
               </a:ext>
             </a:extLst>
           </p:cNvPr>
@@ -10539,7 +10595,7 @@
           <p:cNvPr id="23" name="">
             <a:extLst xmlns:a="http://schemas.openxmlformats.org/drawingml/2006/main">
               <a:ext uri="{FF2B5EF4-FFF2-40B4-BE49-F238E27FC236}">
-                <a16:creationId xmlns:a16="http://schemas.microsoft.com/office/drawing/2014/main" id="{FC543382-95AC-442B-824D-648122D087CA}"/>
+                <a16:creationId xmlns:a16="http://schemas.microsoft.com/office/drawing/2014/main" id="{1B420406-1419-43F9-996D-98B10F1B872C}"/>
               </a:ext>
             </a:extLst>
           </p:cNvPr>
@@ -10629,7 +10685,7 @@
           <p:cNvPr id="24" name="">
             <a:extLst xmlns:a="http://schemas.openxmlformats.org/drawingml/2006/main">
               <a:ext uri="{FF2B5EF4-FFF2-40B4-BE49-F238E27FC236}">
-                <a16:creationId xmlns:a16="http://schemas.microsoft.com/office/drawing/2014/main" id="{D2F21B5F-0615-4807-BB7D-7802B03F571E}"/>
+                <a16:creationId xmlns:a16="http://schemas.microsoft.com/office/drawing/2014/main" id="{12C48F39-4ED1-4BA1-8554-F0DE3308910C}"/>
               </a:ext>
             </a:extLst>
           </p:cNvPr>
@@ -10696,7 +10752,7 @@
           <p:cNvPr id="25" name="">
             <a:extLst xmlns:a="http://schemas.openxmlformats.org/drawingml/2006/main">
               <a:ext uri="{FF2B5EF4-FFF2-40B4-BE49-F238E27FC236}">
-                <a16:creationId xmlns:a16="http://schemas.microsoft.com/office/drawing/2014/main" id="{670B4BB0-79C6-4163-B5B5-11B10E3C943A}"/>
+                <a16:creationId xmlns:a16="http://schemas.microsoft.com/office/drawing/2014/main" id="{620286C0-D2EE-4D78-93CF-6A5D550231A3}"/>
               </a:ext>
             </a:extLst>
           </p:cNvPr>
@@ -10729,7 +10785,7 @@
           <p:cNvPr id="26" name="">
             <a:extLst xmlns:a="http://schemas.openxmlformats.org/drawingml/2006/main">
               <a:ext uri="{FF2B5EF4-FFF2-40B4-BE49-F238E27FC236}">
-                <a16:creationId xmlns:a16="http://schemas.microsoft.com/office/drawing/2014/main" id="{AD1DAED6-E2B5-401D-BA6B-D58FD7CA9FAF}"/>
+                <a16:creationId xmlns:a16="http://schemas.microsoft.com/office/drawing/2014/main" id="{0CD2F16E-92F3-4EA6-B00D-76D6E79147E7}"/>
               </a:ext>
             </a:extLst>
           </p:cNvPr>
@@ -10796,19 +10852,19 @@
           <p:cNvPr id="27" name="">
             <a:extLst xmlns:a="http://schemas.openxmlformats.org/drawingml/2006/main">
               <a:ext uri="{FF2B5EF4-FFF2-40B4-BE49-F238E27FC236}">
-                <a16:creationId xmlns:a16="http://schemas.microsoft.com/office/drawing/2014/main" id="{535E5FFC-C5DC-4AE2-92D3-94FF8193DE88}"/>
-              </a:ext>
-            </a:extLst>
-          </p:cNvPr>
-          <p:cNvSpPr>
-            <a:spLocks xmlns:a="http://schemas.openxmlformats.org/drawingml/2006/main" noGrp="1"/>
-          </p:cNvSpPr>
-          <p:nvPr/>
-        </p:nvSpPr>
-        <p:spPr>
-          <a:xfrm xmlns:a="http://schemas.openxmlformats.org/drawingml/2006/main">
-            <a:off x="7524750" y="6524625"/>
-            <a:ext cx="3981450" cy="171450"/>
+                <a16:creationId xmlns:a16="http://schemas.microsoft.com/office/drawing/2014/main" id="{E6556D30-3F7D-4E0D-AF00-CFEE883D81D9}"/>
+              </a:ext>
+            </a:extLst>
+          </p:cNvPr>
+          <p:cNvSpPr>
+            <a:spLocks xmlns:a="http://schemas.openxmlformats.org/drawingml/2006/main" noGrp="1"/>
+          </p:cNvSpPr>
+          <p:nvPr/>
+        </p:nvSpPr>
+        <p:spPr>
+          <a:xfrm xmlns:a="http://schemas.openxmlformats.org/drawingml/2006/main">
+            <a:off x="7143750" y="6524625"/>
+            <a:ext cx="4362450" cy="171450"/>
           </a:xfrm>
           <a:prstGeom xmlns:a="http://schemas.openxmlformats.org/drawingml/2006/main" prst="rect">
             <a:avLst/>
@@ -10853,7 +10909,7 @@
                 <a:ea typeface="Arial"/>
                 <a:cs typeface="Arial"/>
               </a:rPr>
-              <a:t>Python  |  SQL  |  DuckDB  |  Streamlit</a:t>
+              <a:t>DuckDB  |  FastAPI  |  RabbitMQ  |  Streamlit</a:t>
             </a:r>
           </a:p>
         </p:txBody>
@@ -10861,7 +10917,7 @@
     </p:spTree>
     <p:extLst>
       <p:ext uri="{BB962C8B-B14F-4D97-AF65-F5344CB8AC3E}">
-        <p14:creationId xmlns:p14="http://schemas.microsoft.com/office/powerpoint/2010/main" val="41009086"/>
+        <p14:creationId xmlns:p14="http://schemas.microsoft.com/office/powerpoint/2010/main" val="338472356"/>
       </p:ext>
     </p:extLst>
   </p:cSld>
@@ -10892,7 +10948,7 @@
           <p:cNvPr id="16" name="">
             <a:extLst xmlns:a="http://schemas.openxmlformats.org/drawingml/2006/main">
               <a:ext uri="{FF2B5EF4-FFF2-40B4-BE49-F238E27FC236}">
-                <a16:creationId xmlns:a16="http://schemas.microsoft.com/office/drawing/2014/main" id="{1DCC21F4-308A-49C9-B550-43E23D385147}"/>
+                <a16:creationId xmlns:a16="http://schemas.microsoft.com/office/drawing/2014/main" id="{23C97236-9406-4094-AEB0-29BADC1BD096}"/>
               </a:ext>
             </a:extLst>
           </p:cNvPr>
@@ -10959,7 +11015,7 @@
           <p:cNvPr id="2" name="">
             <a:extLst xmlns:a="http://schemas.openxmlformats.org/drawingml/2006/main">
               <a:ext uri="{FF2B5EF4-FFF2-40B4-BE49-F238E27FC236}">
-                <a16:creationId xmlns:a16="http://schemas.microsoft.com/office/drawing/2014/main" id="{62528E63-247D-4048-A2AE-ACB770C5728C}"/>
+                <a16:creationId xmlns:a16="http://schemas.microsoft.com/office/drawing/2014/main" id="{C3F0606C-A53D-4346-8946-0E211DC8F82A}"/>
               </a:ext>
             </a:extLst>
           </p:cNvPr>
@@ -11026,7 +11082,7 @@
           <p:cNvPr id="3" name="">
             <a:extLst xmlns:a="http://schemas.openxmlformats.org/drawingml/2006/main">
               <a:ext uri="{FF2B5EF4-FFF2-40B4-BE49-F238E27FC236}">
-                <a16:creationId xmlns:a16="http://schemas.microsoft.com/office/drawing/2014/main" id="{0382CC40-E637-4CDE-9CAA-8F7B8EC6E73A}"/>
+                <a16:creationId xmlns:a16="http://schemas.microsoft.com/office/drawing/2014/main" id="{AD2C7403-88C0-4621-9612-A02CB424C61E}"/>
               </a:ext>
             </a:extLst>
           </p:cNvPr>
@@ -11093,7 +11149,7 @@
           <p:cNvPr id="4" name="">
             <a:extLst xmlns:a="http://schemas.openxmlformats.org/drawingml/2006/main">
               <a:ext uri="{FF2B5EF4-FFF2-40B4-BE49-F238E27FC236}">
-                <a16:creationId xmlns:a16="http://schemas.microsoft.com/office/drawing/2014/main" id="{1357055C-67CA-4FED-9F48-CB9212934938}"/>
+                <a16:creationId xmlns:a16="http://schemas.microsoft.com/office/drawing/2014/main" id="{EF108063-A5F6-4B2E-BF1C-82D0CA7CF810}"/>
               </a:ext>
             </a:extLst>
           </p:cNvPr>
@@ -11160,7 +11216,7 @@
           <p:cNvPr id="5" name="">
             <a:extLst xmlns:a="http://schemas.openxmlformats.org/drawingml/2006/main">
               <a:ext uri="{FF2B5EF4-FFF2-40B4-BE49-F238E27FC236}">
-                <a16:creationId xmlns:a16="http://schemas.microsoft.com/office/drawing/2014/main" id="{6EBD70FF-595E-4F34-BC36-381BD3E15B77}"/>
+                <a16:creationId xmlns:a16="http://schemas.microsoft.com/office/drawing/2014/main" id="{6E063004-5AFF-4BDD-9836-57B99DE0B011}"/>
               </a:ext>
             </a:extLst>
           </p:cNvPr>
@@ -11296,7 +11352,7 @@
           <p:cNvPr id="6" name="">
             <a:extLst xmlns:a="http://schemas.openxmlformats.org/drawingml/2006/main">
               <a:ext uri="{FF2B5EF4-FFF2-40B4-BE49-F238E27FC236}">
-                <a16:creationId xmlns:a16="http://schemas.microsoft.com/office/drawing/2014/main" id="{64C54E6C-4792-4EA2-A991-53F357297271}"/>
+                <a16:creationId xmlns:a16="http://schemas.microsoft.com/office/drawing/2014/main" id="{83D25623-08AE-4F14-83FC-F80FE07AE9F2}"/>
               </a:ext>
             </a:extLst>
           </p:cNvPr>
@@ -11363,7 +11419,7 @@
           <p:cNvPr id="7" name="">
             <a:extLst xmlns:a="http://schemas.openxmlformats.org/drawingml/2006/main">
               <a:ext uri="{FF2B5EF4-FFF2-40B4-BE49-F238E27FC236}">
-                <a16:creationId xmlns:a16="http://schemas.microsoft.com/office/drawing/2014/main" id="{E6B9F2D4-6A75-461D-AD51-4783A6C367FE}"/>
+                <a16:creationId xmlns:a16="http://schemas.microsoft.com/office/drawing/2014/main" id="{C4B41AAF-F295-4AC4-84AC-0ED67944F27D}"/>
               </a:ext>
             </a:extLst>
           </p:cNvPr>
@@ -11476,7 +11532,7 @@
           <p:cNvPr id="8" name="">
             <a:extLst xmlns:a="http://schemas.openxmlformats.org/drawingml/2006/main">
               <a:ext uri="{FF2B5EF4-FFF2-40B4-BE49-F238E27FC236}">
-                <a16:creationId xmlns:a16="http://schemas.microsoft.com/office/drawing/2014/main" id="{9C73F650-2AED-43D6-9A03-BA33A4C40D37}"/>
+                <a16:creationId xmlns:a16="http://schemas.microsoft.com/office/drawing/2014/main" id="{63F0948F-B868-4BBF-9243-59CC2FD9ACE2}"/>
               </a:ext>
             </a:extLst>
           </p:cNvPr>
@@ -11543,7 +11599,7 @@
           <p:cNvPr id="9" name="">
             <a:extLst xmlns:a="http://schemas.openxmlformats.org/drawingml/2006/main">
               <a:ext uri="{FF2B5EF4-FFF2-40B4-BE49-F238E27FC236}">
-                <a16:creationId xmlns:a16="http://schemas.microsoft.com/office/drawing/2014/main" id="{0784676A-4AD8-4CFE-B09E-A06E01562F75}"/>
+                <a16:creationId xmlns:a16="http://schemas.microsoft.com/office/drawing/2014/main" id="{A26AC8E4-282B-41B9-A555-A2ED0E1D43F7}"/>
               </a:ext>
             </a:extLst>
           </p:cNvPr>
@@ -11656,7 +11712,7 @@
           <p:cNvPr id="10" name="">
             <a:extLst xmlns:a="http://schemas.openxmlformats.org/drawingml/2006/main">
               <a:ext uri="{FF2B5EF4-FFF2-40B4-BE49-F238E27FC236}">
-                <a16:creationId xmlns:a16="http://schemas.microsoft.com/office/drawing/2014/main" id="{BA138966-3E91-47BC-9D93-BCC2D0920EBA}"/>
+                <a16:creationId xmlns:a16="http://schemas.microsoft.com/office/drawing/2014/main" id="{1E9FDC8A-3A57-4C02-AB57-70F02B1EFD8F}"/>
               </a:ext>
             </a:extLst>
           </p:cNvPr>
@@ -11723,7 +11779,7 @@
           <p:cNvPr id="11" name="">
             <a:extLst xmlns:a="http://schemas.openxmlformats.org/drawingml/2006/main">
               <a:ext uri="{FF2B5EF4-FFF2-40B4-BE49-F238E27FC236}">
-                <a16:creationId xmlns:a16="http://schemas.microsoft.com/office/drawing/2014/main" id="{D915A260-53E0-4DF7-BF84-8D985D9E0AF6}"/>
+                <a16:creationId xmlns:a16="http://schemas.microsoft.com/office/drawing/2014/main" id="{BCE6F071-DD70-4E87-91C8-30E71AD854F5}"/>
               </a:ext>
             </a:extLst>
           </p:cNvPr>
@@ -11758,7 +11814,7 @@
           <p:cNvPr id="12" name="">
             <a:extLst xmlns:a="http://schemas.openxmlformats.org/drawingml/2006/main">
               <a:ext uri="{FF2B5EF4-FFF2-40B4-BE49-F238E27FC236}">
-                <a16:creationId xmlns:a16="http://schemas.microsoft.com/office/drawing/2014/main" id="{D6E1606E-1600-43A8-88F8-6D4B93D64026}"/>
+                <a16:creationId xmlns:a16="http://schemas.microsoft.com/office/drawing/2014/main" id="{FE406CC7-D72B-44DC-A69A-A3B98C6B5E85}"/>
               </a:ext>
             </a:extLst>
           </p:cNvPr>
@@ -11871,7 +11927,7 @@
           <p:cNvPr id="13" name="">
             <a:extLst xmlns:a="http://schemas.openxmlformats.org/drawingml/2006/main">
               <a:ext uri="{FF2B5EF4-FFF2-40B4-BE49-F238E27FC236}">
-                <a16:creationId xmlns:a16="http://schemas.microsoft.com/office/drawing/2014/main" id="{8B8DB93C-E13A-4F62-8FFF-3C36D6FBFC19}"/>
+                <a16:creationId xmlns:a16="http://schemas.microsoft.com/office/drawing/2014/main" id="{051ECAF9-A267-4205-8487-6D7CD0223A36}"/>
               </a:ext>
             </a:extLst>
           </p:cNvPr>
@@ -11904,7 +11960,7 @@
           <p:cNvPr id="14" name="">
             <a:extLst xmlns:a="http://schemas.openxmlformats.org/drawingml/2006/main">
               <a:ext uri="{FF2B5EF4-FFF2-40B4-BE49-F238E27FC236}">
-                <a16:creationId xmlns:a16="http://schemas.microsoft.com/office/drawing/2014/main" id="{27E73114-EAAA-49DB-A4AA-D87AE66F5444}"/>
+                <a16:creationId xmlns:a16="http://schemas.microsoft.com/office/drawing/2014/main" id="{67AF77A3-2D2F-4DB5-9664-D1445BF7A6D1}"/>
               </a:ext>
             </a:extLst>
           </p:cNvPr>
@@ -11971,19 +12027,19 @@
           <p:cNvPr id="15" name="">
             <a:extLst xmlns:a="http://schemas.openxmlformats.org/drawingml/2006/main">
               <a:ext uri="{FF2B5EF4-FFF2-40B4-BE49-F238E27FC236}">
-                <a16:creationId xmlns:a16="http://schemas.microsoft.com/office/drawing/2014/main" id="{9452F48E-C6E0-469D-8E04-891B435B480B}"/>
-              </a:ext>
-            </a:extLst>
-          </p:cNvPr>
-          <p:cNvSpPr>
-            <a:spLocks xmlns:a="http://schemas.openxmlformats.org/drawingml/2006/main" noGrp="1"/>
-          </p:cNvSpPr>
-          <p:nvPr/>
-        </p:nvSpPr>
-        <p:spPr>
-          <a:xfrm xmlns:a="http://schemas.openxmlformats.org/drawingml/2006/main">
-            <a:off x="7524750" y="6524625"/>
-            <a:ext cx="3981450" cy="171450"/>
+                <a16:creationId xmlns:a16="http://schemas.microsoft.com/office/drawing/2014/main" id="{04AFA009-3EB0-4269-B0A3-CD3EC97F8A6D}"/>
+              </a:ext>
+            </a:extLst>
+          </p:cNvPr>
+          <p:cNvSpPr>
+            <a:spLocks xmlns:a="http://schemas.openxmlformats.org/drawingml/2006/main" noGrp="1"/>
+          </p:cNvSpPr>
+          <p:nvPr/>
+        </p:nvSpPr>
+        <p:spPr>
+          <a:xfrm xmlns:a="http://schemas.openxmlformats.org/drawingml/2006/main">
+            <a:off x="7143750" y="6524625"/>
+            <a:ext cx="4362450" cy="171450"/>
           </a:xfrm>
           <a:prstGeom xmlns:a="http://schemas.openxmlformats.org/drawingml/2006/main" prst="rect">
             <a:avLst/>
@@ -12028,7 +12084,7 @@
                 <a:ea typeface="Arial"/>
                 <a:cs typeface="Arial"/>
               </a:rPr>
-              <a:t>Python  |  SQL  |  DuckDB  |  Streamlit</a:t>
+              <a:t>DuckDB  |  FastAPI  |  RabbitMQ  |  Streamlit</a:t>
             </a:r>
           </a:p>
         </p:txBody>
@@ -12036,7 +12092,7 @@
     </p:spTree>
     <p:extLst>
       <p:ext uri="{BB962C8B-B14F-4D97-AF65-F5344CB8AC3E}">
-        <p14:creationId xmlns:p14="http://schemas.microsoft.com/office/powerpoint/2010/main" val="59478481"/>
+        <p14:creationId xmlns:p14="http://schemas.microsoft.com/office/powerpoint/2010/main" val="294029046"/>
       </p:ext>
     </p:extLst>
   </p:cSld>
@@ -12067,7 +12123,7 @@
           <p:cNvPr id="17" name="">
             <a:extLst xmlns:a="http://schemas.openxmlformats.org/drawingml/2006/main">
               <a:ext uri="{FF2B5EF4-FFF2-40B4-BE49-F238E27FC236}">
-                <a16:creationId xmlns:a16="http://schemas.microsoft.com/office/drawing/2014/main" id="{7BB34695-0C86-4483-B06C-DA3A042BBE86}"/>
+                <a16:creationId xmlns:a16="http://schemas.microsoft.com/office/drawing/2014/main" id="{0AA8A623-FBD6-4FCD-BD51-F1417B051D0A}"/>
               </a:ext>
             </a:extLst>
           </p:cNvPr>
@@ -12134,7 +12190,7 @@
           <p:cNvPr id="2" name="">
             <a:extLst xmlns:a="http://schemas.openxmlformats.org/drawingml/2006/main">
               <a:ext uri="{FF2B5EF4-FFF2-40B4-BE49-F238E27FC236}">
-                <a16:creationId xmlns:a16="http://schemas.microsoft.com/office/drawing/2014/main" id="{9CAE4AE9-E711-411C-8541-2FE70DF1B569}"/>
+                <a16:creationId xmlns:a16="http://schemas.microsoft.com/office/drawing/2014/main" id="{B3E68F1A-C860-45D3-BCFC-7A7A889189FB}"/>
               </a:ext>
             </a:extLst>
           </p:cNvPr>
@@ -12201,7 +12257,7 @@
           <p:cNvPr id="3" name="">
             <a:extLst xmlns:a="http://schemas.openxmlformats.org/drawingml/2006/main">
               <a:ext uri="{FF2B5EF4-FFF2-40B4-BE49-F238E27FC236}">
-                <a16:creationId xmlns:a16="http://schemas.microsoft.com/office/drawing/2014/main" id="{27C88F83-909C-4855-809C-2C5279936AEB}"/>
+                <a16:creationId xmlns:a16="http://schemas.microsoft.com/office/drawing/2014/main" id="{AC5B2E24-5C33-49B7-A448-F7CAB54705E7}"/>
               </a:ext>
             </a:extLst>
           </p:cNvPr>
@@ -12268,7 +12324,7 @@
           <p:cNvPr id="4" name="">
             <a:extLst xmlns:a="http://schemas.openxmlformats.org/drawingml/2006/main">
               <a:ext uri="{FF2B5EF4-FFF2-40B4-BE49-F238E27FC236}">
-                <a16:creationId xmlns:a16="http://schemas.microsoft.com/office/drawing/2014/main" id="{4DE9C9BA-3263-453E-8674-73039A3DD037}"/>
+                <a16:creationId xmlns:a16="http://schemas.microsoft.com/office/drawing/2014/main" id="{55266579-04C1-4F44-AF22-1CEFD3244A98}"/>
               </a:ext>
             </a:extLst>
           </p:cNvPr>
@@ -12335,7 +12391,7 @@
           <p:cNvPr id="5" name="">
             <a:extLst xmlns:a="http://schemas.openxmlformats.org/drawingml/2006/main">
               <a:ext uri="{FF2B5EF4-FFF2-40B4-BE49-F238E27FC236}">
-                <a16:creationId xmlns:a16="http://schemas.microsoft.com/office/drawing/2014/main" id="{632C3A4F-9C2A-4AA8-A16E-6A81B5B237E4}"/>
+                <a16:creationId xmlns:a16="http://schemas.microsoft.com/office/drawing/2014/main" id="{3E7ADADA-B010-4D4F-968D-9D8C260CD1C6}"/>
               </a:ext>
             </a:extLst>
           </p:cNvPr>
@@ -12402,7 +12458,7 @@
           <p:cNvPr id="6" name="">
             <a:extLst xmlns:a="http://schemas.openxmlformats.org/drawingml/2006/main">
               <a:ext uri="{FF2B5EF4-FFF2-40B4-BE49-F238E27FC236}">
-                <a16:creationId xmlns:a16="http://schemas.microsoft.com/office/drawing/2014/main" id="{B62DF5E0-8EF9-44F5-A66B-E9F4F2D901DF}"/>
+                <a16:creationId xmlns:a16="http://schemas.microsoft.com/office/drawing/2014/main" id="{4F4914CF-0B46-49B1-8972-656BB1893204}"/>
               </a:ext>
             </a:extLst>
           </p:cNvPr>
@@ -12469,7 +12525,7 @@
           <p:cNvPr id="7" name="">
             <a:extLst xmlns:a="http://schemas.openxmlformats.org/drawingml/2006/main">
               <a:ext uri="{FF2B5EF4-FFF2-40B4-BE49-F238E27FC236}">
-                <a16:creationId xmlns:a16="http://schemas.microsoft.com/office/drawing/2014/main" id="{4F8E581F-017E-455E-98B3-F58AC42F0B5F}"/>
+                <a16:creationId xmlns:a16="http://schemas.microsoft.com/office/drawing/2014/main" id="{35076884-CEEE-40D7-A9E7-221398018D04}"/>
               </a:ext>
             </a:extLst>
           </p:cNvPr>
@@ -12536,7 +12592,7 @@
           <p:cNvPr id="8" name="">
             <a:extLst xmlns:a="http://schemas.openxmlformats.org/drawingml/2006/main">
               <a:ext uri="{FF2B5EF4-FFF2-40B4-BE49-F238E27FC236}">
-                <a16:creationId xmlns:a16="http://schemas.microsoft.com/office/drawing/2014/main" id="{577C36AD-A29B-4EDC-9F37-65BA152F899B}"/>
+                <a16:creationId xmlns:a16="http://schemas.microsoft.com/office/drawing/2014/main" id="{47F0B82F-B3EE-4934-B405-A237579707F8}"/>
               </a:ext>
             </a:extLst>
           </p:cNvPr>
@@ -12603,7 +12659,7 @@
           <p:cNvPr id="9" name="">
             <a:extLst xmlns:a="http://schemas.openxmlformats.org/drawingml/2006/main">
               <a:ext uri="{FF2B5EF4-FFF2-40B4-BE49-F238E27FC236}">
-                <a16:creationId xmlns:a16="http://schemas.microsoft.com/office/drawing/2014/main" id="{AA4CD3CF-2DB5-47E5-8E9A-2C404B937F9F}"/>
+                <a16:creationId xmlns:a16="http://schemas.microsoft.com/office/drawing/2014/main" id="{4BDE7366-08AF-4F3D-A51C-E96E1EEA83A8}"/>
               </a:ext>
             </a:extLst>
           </p:cNvPr>
@@ -12670,7 +12726,7 @@
           <p:cNvPr id="10" name="">
             <a:extLst xmlns:a="http://schemas.openxmlformats.org/drawingml/2006/main">
               <a:ext uri="{FF2B5EF4-FFF2-40B4-BE49-F238E27FC236}">
-                <a16:creationId xmlns:a16="http://schemas.microsoft.com/office/drawing/2014/main" id="{467B27C1-88CB-4C27-8723-D00DC44CBCC0}"/>
+                <a16:creationId xmlns:a16="http://schemas.microsoft.com/office/drawing/2014/main" id="{DA164CD4-F1BE-4A95-B519-EACAB6806D2D}"/>
               </a:ext>
             </a:extLst>
           </p:cNvPr>
@@ -12737,7 +12793,7 @@
           <p:cNvPr id="11" name="">
             <a:extLst xmlns:a="http://schemas.openxmlformats.org/drawingml/2006/main">
               <a:ext uri="{FF2B5EF4-FFF2-40B4-BE49-F238E27FC236}">
-                <a16:creationId xmlns:a16="http://schemas.microsoft.com/office/drawing/2014/main" id="{7800E019-E475-4C72-B3DF-93D33A3DEF98}"/>
+                <a16:creationId xmlns:a16="http://schemas.microsoft.com/office/drawing/2014/main" id="{4FA54FA9-AE9C-4D3B-8B00-B75C68349008}"/>
               </a:ext>
             </a:extLst>
           </p:cNvPr>
@@ -12804,7 +12860,7 @@
           <p:cNvPr id="12" name="Chart">
             <a:extLst xmlns:a="http://schemas.openxmlformats.org/drawingml/2006/main">
               <a:ext uri="{FF2B5EF4-FFF2-40B4-BE49-F238E27FC236}">
-                <a16:creationId xmlns:a16="http://schemas.microsoft.com/office/drawing/2014/main" id="{FE816803-03EE-4646-A646-EDEDBD75E4BF}"/>
+                <a16:creationId xmlns:a16="http://schemas.microsoft.com/office/drawing/2014/main" id="{559EA36C-25D3-43A4-A68D-ED2EAD13F1DD}"/>
               </a:ext>
             </a:extLst>
           </p:cNvPr>
@@ -12817,7 +12873,7 @@
         </p:xfrm>
         <a:graphic xmlns:a="http://schemas.openxmlformats.org/drawingml/2006/main">
           <a:graphicData uri="http://schemas.openxmlformats.org/drawingml/2006/chart">
-            <c:chart xmlns:r="http://schemas.openxmlformats.org/officeDocument/2006/relationships" xmlns:c="http://schemas.openxmlformats.org/drawingml/2006/chart" r:id="R31079c9c75d64e43"/>
+            <c:chart xmlns:r="http://schemas.openxmlformats.org/officeDocument/2006/relationships" xmlns:c="http://schemas.openxmlformats.org/drawingml/2006/chart" r:id="Ref5fe100ba004be1"/>
           </a:graphicData>
         </a:graphic>
       </p:graphicFrame>
@@ -12826,7 +12882,7 @@
           <p:cNvPr id="13" name="">
             <a:extLst xmlns:a="http://schemas.openxmlformats.org/drawingml/2006/main">
               <a:ext uri="{FF2B5EF4-FFF2-40B4-BE49-F238E27FC236}">
-                <a16:creationId xmlns:a16="http://schemas.microsoft.com/office/drawing/2014/main" id="{03515EDF-4DB5-4011-B7F4-A4ED6B24C393}"/>
+                <a16:creationId xmlns:a16="http://schemas.microsoft.com/office/drawing/2014/main" id="{09D9CABF-1098-4BEB-B93E-7270682D72EC}"/>
               </a:ext>
             </a:extLst>
           </p:cNvPr>
@@ -12893,7 +12949,7 @@
           <p:cNvPr id="14" name="">
             <a:extLst xmlns:a="http://schemas.openxmlformats.org/drawingml/2006/main">
               <a:ext uri="{FF2B5EF4-FFF2-40B4-BE49-F238E27FC236}">
-                <a16:creationId xmlns:a16="http://schemas.microsoft.com/office/drawing/2014/main" id="{B5BEBE26-0ED2-48B9-823A-CEA82846A0B8}"/>
+                <a16:creationId xmlns:a16="http://schemas.microsoft.com/office/drawing/2014/main" id="{2EDCE5F1-E2AC-4C1B-9148-EF68A62854EA}"/>
               </a:ext>
             </a:extLst>
           </p:cNvPr>
@@ -12926,7 +12982,7 @@
           <p:cNvPr id="15" name="">
             <a:extLst xmlns:a="http://schemas.openxmlformats.org/drawingml/2006/main">
               <a:ext uri="{FF2B5EF4-FFF2-40B4-BE49-F238E27FC236}">
-                <a16:creationId xmlns:a16="http://schemas.microsoft.com/office/drawing/2014/main" id="{7F051A91-ED9C-4C8D-83AF-8DB436568F22}"/>
+                <a16:creationId xmlns:a16="http://schemas.microsoft.com/office/drawing/2014/main" id="{BE5AC5C6-1343-4F55-9D91-AFED887E41F8}"/>
               </a:ext>
             </a:extLst>
           </p:cNvPr>
@@ -12993,19 +13049,19 @@
           <p:cNvPr id="16" name="">
             <a:extLst xmlns:a="http://schemas.openxmlformats.org/drawingml/2006/main">
               <a:ext uri="{FF2B5EF4-FFF2-40B4-BE49-F238E27FC236}">
-                <a16:creationId xmlns:a16="http://schemas.microsoft.com/office/drawing/2014/main" id="{20ED708A-A588-4C26-B1D6-FB070DA387C1}"/>
-              </a:ext>
-            </a:extLst>
-          </p:cNvPr>
-          <p:cNvSpPr>
-            <a:spLocks xmlns:a="http://schemas.openxmlformats.org/drawingml/2006/main" noGrp="1"/>
-          </p:cNvSpPr>
-          <p:nvPr/>
-        </p:nvSpPr>
-        <p:spPr>
-          <a:xfrm xmlns:a="http://schemas.openxmlformats.org/drawingml/2006/main">
-            <a:off x="7524750" y="6524625"/>
-            <a:ext cx="3981450" cy="171450"/>
+                <a16:creationId xmlns:a16="http://schemas.microsoft.com/office/drawing/2014/main" id="{8C435491-E2F4-45E9-B4B2-EF2F1D91986A}"/>
+              </a:ext>
+            </a:extLst>
+          </p:cNvPr>
+          <p:cNvSpPr>
+            <a:spLocks xmlns:a="http://schemas.openxmlformats.org/drawingml/2006/main" noGrp="1"/>
+          </p:cNvSpPr>
+          <p:nvPr/>
+        </p:nvSpPr>
+        <p:spPr>
+          <a:xfrm xmlns:a="http://schemas.openxmlformats.org/drawingml/2006/main">
+            <a:off x="7143750" y="6524625"/>
+            <a:ext cx="4362450" cy="171450"/>
           </a:xfrm>
           <a:prstGeom xmlns:a="http://schemas.openxmlformats.org/drawingml/2006/main" prst="rect">
             <a:avLst/>
@@ -13050,7 +13106,7 @@
                 <a:ea typeface="Arial"/>
                 <a:cs typeface="Arial"/>
               </a:rPr>
-              <a:t>Python  |  SQL  |  DuckDB  |  Streamlit</a:t>
+              <a:t>DuckDB  |  FastAPI  |  RabbitMQ  |  Streamlit</a:t>
             </a:r>
           </a:p>
         </p:txBody>
@@ -13058,7 +13114,7 @@
     </p:spTree>
     <p:extLst>
       <p:ext uri="{BB962C8B-B14F-4D97-AF65-F5344CB8AC3E}">
-        <p14:creationId xmlns:p14="http://schemas.microsoft.com/office/powerpoint/2010/main" val="51104517"/>
+        <p14:creationId xmlns:p14="http://schemas.microsoft.com/office/powerpoint/2010/main" val="575927119"/>
       </p:ext>
     </p:extLst>
   </p:cSld>
@@ -13089,7 +13145,7 @@
           <p:cNvPr id="5" name="">
             <a:extLst xmlns:a="http://schemas.openxmlformats.org/drawingml/2006/main">
               <a:ext uri="{FF2B5EF4-FFF2-40B4-BE49-F238E27FC236}">
-                <a16:creationId xmlns:a16="http://schemas.microsoft.com/office/drawing/2014/main" id="{9FE1706F-DC3D-4BC3-B513-B12A6B67264C}"/>
+                <a16:creationId xmlns:a16="http://schemas.microsoft.com/office/drawing/2014/main" id="{0E30EF9D-D94B-477D-A06A-B562832D0F3D}"/>
               </a:ext>
             </a:extLst>
           </p:cNvPr>
@@ -13156,7 +13212,7 @@
           <p:cNvPr id="2" name="">
             <a:extLst xmlns:a="http://schemas.openxmlformats.org/drawingml/2006/main">
               <a:ext uri="{FF2B5EF4-FFF2-40B4-BE49-F238E27FC236}">
-                <a16:creationId xmlns:a16="http://schemas.microsoft.com/office/drawing/2014/main" id="{C78772DD-39A0-440B-B9CA-D4680178AF72}"/>
+                <a16:creationId xmlns:a16="http://schemas.microsoft.com/office/drawing/2014/main" id="{61A4A3C8-D88D-4BBD-B108-61A00E22E651}"/>
               </a:ext>
             </a:extLst>
           </p:cNvPr>
@@ -13223,7 +13279,7 @@
           <p:cNvPr id="3" name="">
             <a:extLst xmlns:a="http://schemas.openxmlformats.org/drawingml/2006/main">
               <a:ext uri="{FF2B5EF4-FFF2-40B4-BE49-F238E27FC236}">
-                <a16:creationId xmlns:a16="http://schemas.microsoft.com/office/drawing/2014/main" id="{3A5438FD-193D-4B10-8464-56E9D30EFE6E}"/>
+                <a16:creationId xmlns:a16="http://schemas.microsoft.com/office/drawing/2014/main" id="{E06857AF-A852-4AEB-8B4C-E5776BE8C37B}"/>
               </a:ext>
             </a:extLst>
           </p:cNvPr>
@@ -13280,7 +13336,7 @@
                 <a:ea typeface="Arial"/>
                 <a:cs typeface="Arial"/>
               </a:rPr>
-              <a:t>Date, region and category filters update four KPIs, four charts and a top-products table</a:t>
+              <a:t>Historical KPIs and live order metrics share one decision-focused interface</a:t>
             </a:r>
           </a:p>
         </p:txBody>
@@ -13290,7 +13346,7 @@
           <p:cNvPr id="4" name="">
             <a:extLst xmlns:a="http://schemas.openxmlformats.org/drawingml/2006/main">
               <a:ext uri="{FF2B5EF4-FFF2-40B4-BE49-F238E27FC236}">
-                <a16:creationId xmlns:a16="http://schemas.microsoft.com/office/drawing/2014/main" id="{5A11024C-7C48-440D-B32F-8D229005E76C}"/>
+                <a16:creationId xmlns:a16="http://schemas.microsoft.com/office/drawing/2014/main" id="{97975B48-006F-4D0F-9468-29F2F397DCDC}"/>
               </a:ext>
             </a:extLst>
           </p:cNvPr>
@@ -13300,7 +13356,7 @@
           <p:nvPr/>
         </p:nvPicPr>
         <p:blipFill>
-          <a:blip xmlns:r="http://schemas.openxmlformats.org/officeDocument/2006/relationships" xmlns:a="http://schemas.openxmlformats.org/drawingml/2006/main" r:embed="Rc0330e9acb5e4136"/>
+          <a:blip xmlns:r="http://schemas.openxmlformats.org/officeDocument/2006/relationships" xmlns:a="http://schemas.openxmlformats.org/drawingml/2006/main" r:embed="R4dc72023fa284b2c"/>
           <a:stretch xmlns:a="http://schemas.openxmlformats.org/drawingml/2006/main"/>
         </p:blipFill>
         <p:spPr>
@@ -13316,7 +13372,7 @@
     </p:spTree>
     <p:extLst>
       <p:ext uri="{BB962C8B-B14F-4D97-AF65-F5344CB8AC3E}">
-        <p14:creationId xmlns:p14="http://schemas.microsoft.com/office/powerpoint/2010/main" val="744471129"/>
+        <p14:creationId xmlns:p14="http://schemas.microsoft.com/office/powerpoint/2010/main" val="632754732"/>
       </p:ext>
     </p:extLst>
   </p:cSld>
@@ -13347,7 +13403,7 @@
           <p:cNvPr id="12" name="">
             <a:extLst xmlns:a="http://schemas.openxmlformats.org/drawingml/2006/main">
               <a:ext uri="{FF2B5EF4-FFF2-40B4-BE49-F238E27FC236}">
-                <a16:creationId xmlns:a16="http://schemas.microsoft.com/office/drawing/2014/main" id="{A331CBE6-FD0C-4A55-99F4-37280BF752C0}"/>
+                <a16:creationId xmlns:a16="http://schemas.microsoft.com/office/drawing/2014/main" id="{5DDD3D8B-6C05-44D5-B93B-B7D827CAF30D}"/>
               </a:ext>
             </a:extLst>
           </p:cNvPr>
@@ -13414,7 +13470,7 @@
           <p:cNvPr id="2" name="">
             <a:extLst xmlns:a="http://schemas.openxmlformats.org/drawingml/2006/main">
               <a:ext uri="{FF2B5EF4-FFF2-40B4-BE49-F238E27FC236}">
-                <a16:creationId xmlns:a16="http://schemas.microsoft.com/office/drawing/2014/main" id="{41649BFC-7B96-4D1E-9009-8BA3E236BDE1}"/>
+                <a16:creationId xmlns:a16="http://schemas.microsoft.com/office/drawing/2014/main" id="{9E11E39B-266B-48A6-8815-905FE44227B2}"/>
               </a:ext>
             </a:extLst>
           </p:cNvPr>
@@ -13481,7 +13537,7 @@
           <p:cNvPr id="3" name="">
             <a:extLst xmlns:a="http://schemas.openxmlformats.org/drawingml/2006/main">
               <a:ext uri="{FF2B5EF4-FFF2-40B4-BE49-F238E27FC236}">
-                <a16:creationId xmlns:a16="http://schemas.microsoft.com/office/drawing/2014/main" id="{B1E17477-D3B0-4EB2-B105-6527FE28D655}"/>
+                <a16:creationId xmlns:a16="http://schemas.microsoft.com/office/drawing/2014/main" id="{173DCF11-B7CB-48CB-BA86-2D79028FBB74}"/>
               </a:ext>
             </a:extLst>
           </p:cNvPr>
@@ -13548,7 +13604,7 @@
           <p:cNvPr id="4" name="Chart">
             <a:extLst xmlns:a="http://schemas.openxmlformats.org/drawingml/2006/main">
               <a:ext uri="{FF2B5EF4-FFF2-40B4-BE49-F238E27FC236}">
-                <a16:creationId xmlns:a16="http://schemas.microsoft.com/office/drawing/2014/main" id="{D7184D5A-9B6F-43A2-B238-184DDC3A06E0}"/>
+                <a16:creationId xmlns:a16="http://schemas.microsoft.com/office/drawing/2014/main" id="{9F91594A-CF4E-4FCB-BC59-4F70E8A52D48}"/>
               </a:ext>
             </a:extLst>
           </p:cNvPr>
@@ -13561,7 +13617,7 @@
         </p:xfrm>
         <a:graphic xmlns:a="http://schemas.openxmlformats.org/drawingml/2006/main">
           <a:graphicData uri="http://schemas.openxmlformats.org/drawingml/2006/chart">
-            <c:chart xmlns:r="http://schemas.openxmlformats.org/officeDocument/2006/relationships" xmlns:c="http://schemas.openxmlformats.org/drawingml/2006/chart" r:id="Re7dc7294b26b4e06"/>
+            <c:chart xmlns:r="http://schemas.openxmlformats.org/officeDocument/2006/relationships" xmlns:c="http://schemas.openxmlformats.org/drawingml/2006/chart" r:id="R93f0f097049f439f"/>
           </a:graphicData>
         </a:graphic>
       </p:graphicFrame>
@@ -13570,7 +13626,7 @@
           <p:cNvPr id="5" name="">
             <a:extLst xmlns:a="http://schemas.openxmlformats.org/drawingml/2006/main">
               <a:ext uri="{FF2B5EF4-FFF2-40B4-BE49-F238E27FC236}">
-                <a16:creationId xmlns:a16="http://schemas.microsoft.com/office/drawing/2014/main" id="{F1F5BFE4-707F-4E3C-9E11-A4509D446445}"/>
+                <a16:creationId xmlns:a16="http://schemas.microsoft.com/office/drawing/2014/main" id="{A556D00E-8549-48F4-A372-734829198B2A}"/>
               </a:ext>
             </a:extLst>
           </p:cNvPr>
@@ -14045,7 +14101,7 @@
           <p:cNvPr id="6" name="">
             <a:extLst xmlns:a="http://schemas.openxmlformats.org/drawingml/2006/main">
               <a:ext uri="{FF2B5EF4-FFF2-40B4-BE49-F238E27FC236}">
-                <a16:creationId xmlns:a16="http://schemas.microsoft.com/office/drawing/2014/main" id="{C2CB649C-8EA9-48CA-800B-48A556752EC0}"/>
+                <a16:creationId xmlns:a16="http://schemas.microsoft.com/office/drawing/2014/main" id="{C9262908-C4F0-4E28-A9B9-68AD447BCE88}"/>
               </a:ext>
             </a:extLst>
           </p:cNvPr>
@@ -14112,7 +14168,7 @@
           <p:cNvPr id="7" name="">
             <a:extLst xmlns:a="http://schemas.openxmlformats.org/drawingml/2006/main">
               <a:ext uri="{FF2B5EF4-FFF2-40B4-BE49-F238E27FC236}">
-                <a16:creationId xmlns:a16="http://schemas.microsoft.com/office/drawing/2014/main" id="{7733D140-5612-4BE8-A889-FC757190F170}"/>
+                <a16:creationId xmlns:a16="http://schemas.microsoft.com/office/drawing/2014/main" id="{93E548F6-716A-434E-AD84-C799EF6796D6}"/>
               </a:ext>
             </a:extLst>
           </p:cNvPr>
@@ -14179,7 +14235,7 @@
           <p:cNvPr id="8" name="">
             <a:extLst xmlns:a="http://schemas.openxmlformats.org/drawingml/2006/main">
               <a:ext uri="{FF2B5EF4-FFF2-40B4-BE49-F238E27FC236}">
-                <a16:creationId xmlns:a16="http://schemas.microsoft.com/office/drawing/2014/main" id="{B2AECC4D-90BD-43C5-848D-ECE4B6489A3A}"/>
+                <a16:creationId xmlns:a16="http://schemas.microsoft.com/office/drawing/2014/main" id="{74D32E62-98D6-4770-928A-02B0CE554EBE}"/>
               </a:ext>
             </a:extLst>
           </p:cNvPr>
@@ -14246,7 +14302,7 @@
           <p:cNvPr id="9" name="">
             <a:extLst xmlns:a="http://schemas.openxmlformats.org/drawingml/2006/main">
               <a:ext uri="{FF2B5EF4-FFF2-40B4-BE49-F238E27FC236}">
-                <a16:creationId xmlns:a16="http://schemas.microsoft.com/office/drawing/2014/main" id="{9AB86C21-B6F3-4E1E-9718-DC00B055E3EE}"/>
+                <a16:creationId xmlns:a16="http://schemas.microsoft.com/office/drawing/2014/main" id="{A69AB613-EB9A-42C6-A3B7-331D2A34073F}"/>
               </a:ext>
             </a:extLst>
           </p:cNvPr>
@@ -14279,7 +14335,7 @@
           <p:cNvPr id="10" name="">
             <a:extLst xmlns:a="http://schemas.openxmlformats.org/drawingml/2006/main">
               <a:ext uri="{FF2B5EF4-FFF2-40B4-BE49-F238E27FC236}">
-                <a16:creationId xmlns:a16="http://schemas.microsoft.com/office/drawing/2014/main" id="{A3B559A1-B4C1-47CF-80D0-751A9AFEAF2B}"/>
+                <a16:creationId xmlns:a16="http://schemas.microsoft.com/office/drawing/2014/main" id="{5513F0B1-EF20-4F1B-A47A-F319DB6E7172}"/>
               </a:ext>
             </a:extLst>
           </p:cNvPr>
@@ -14346,19 +14402,19 @@
           <p:cNvPr id="11" name="">
             <a:extLst xmlns:a="http://schemas.openxmlformats.org/drawingml/2006/main">
               <a:ext uri="{FF2B5EF4-FFF2-40B4-BE49-F238E27FC236}">
-                <a16:creationId xmlns:a16="http://schemas.microsoft.com/office/drawing/2014/main" id="{125D0F34-8613-41FF-BFEB-2CC2C99DF410}"/>
-              </a:ext>
-            </a:extLst>
-          </p:cNvPr>
-          <p:cNvSpPr>
-            <a:spLocks xmlns:a="http://schemas.openxmlformats.org/drawingml/2006/main" noGrp="1"/>
-          </p:cNvSpPr>
-          <p:nvPr/>
-        </p:nvSpPr>
-        <p:spPr>
-          <a:xfrm xmlns:a="http://schemas.openxmlformats.org/drawingml/2006/main">
-            <a:off x="7524750" y="6524625"/>
-            <a:ext cx="3981450" cy="171450"/>
+                <a16:creationId xmlns:a16="http://schemas.microsoft.com/office/drawing/2014/main" id="{F1563AE0-9C1C-4F61-B30F-DA741321315C}"/>
+              </a:ext>
+            </a:extLst>
+          </p:cNvPr>
+          <p:cNvSpPr>
+            <a:spLocks xmlns:a="http://schemas.openxmlformats.org/drawingml/2006/main" noGrp="1"/>
+          </p:cNvSpPr>
+          <p:nvPr/>
+        </p:nvSpPr>
+        <p:spPr>
+          <a:xfrm xmlns:a="http://schemas.openxmlformats.org/drawingml/2006/main">
+            <a:off x="7143750" y="6524625"/>
+            <a:ext cx="4362450" cy="171450"/>
           </a:xfrm>
           <a:prstGeom xmlns:a="http://schemas.openxmlformats.org/drawingml/2006/main" prst="rect">
             <a:avLst/>
@@ -14403,7 +14459,7 @@
                 <a:ea typeface="Arial"/>
                 <a:cs typeface="Arial"/>
               </a:rPr>
-              <a:t>Python  |  SQL  |  DuckDB  |  Streamlit</a:t>
+              <a:t>DuckDB  |  FastAPI  |  RabbitMQ  |  Streamlit</a:t>
             </a:r>
           </a:p>
         </p:txBody>
@@ -14411,7 +14467,7 @@
     </p:spTree>
     <p:extLst>
       <p:ext uri="{BB962C8B-B14F-4D97-AF65-F5344CB8AC3E}">
-        <p14:creationId xmlns:p14="http://schemas.microsoft.com/office/powerpoint/2010/main" val="1986489265"/>
+        <p14:creationId xmlns:p14="http://schemas.microsoft.com/office/powerpoint/2010/main" val="833364588"/>
       </p:ext>
     </p:extLst>
   </p:cSld>
@@ -14442,7 +14498,7 @@
           <p:cNvPr id="24" name="">
             <a:extLst xmlns:a="http://schemas.openxmlformats.org/drawingml/2006/main">
               <a:ext uri="{FF2B5EF4-FFF2-40B4-BE49-F238E27FC236}">
-                <a16:creationId xmlns:a16="http://schemas.microsoft.com/office/drawing/2014/main" id="{91619E0A-3C8D-4279-8C17-09ED2B0786C5}"/>
+                <a16:creationId xmlns:a16="http://schemas.microsoft.com/office/drawing/2014/main" id="{DE5B4120-49DB-4D27-92E6-8DEE274ACD22}"/>
               </a:ext>
             </a:extLst>
           </p:cNvPr>
@@ -14509,7 +14565,7 @@
           <p:cNvPr id="2" name="">
             <a:extLst xmlns:a="http://schemas.openxmlformats.org/drawingml/2006/main">
               <a:ext uri="{FF2B5EF4-FFF2-40B4-BE49-F238E27FC236}">
-                <a16:creationId xmlns:a16="http://schemas.microsoft.com/office/drawing/2014/main" id="{2DF7A17B-E2B2-4309-9BF7-1C5A1EED4F77}"/>
+                <a16:creationId xmlns:a16="http://schemas.microsoft.com/office/drawing/2014/main" id="{56CB3A59-9B79-4D3C-BB14-824DC6CA197C}"/>
               </a:ext>
             </a:extLst>
           </p:cNvPr>
@@ -14576,7 +14632,7 @@
           <p:cNvPr id="3" name="">
             <a:extLst xmlns:a="http://schemas.openxmlformats.org/drawingml/2006/main">
               <a:ext uri="{FF2B5EF4-FFF2-40B4-BE49-F238E27FC236}">
-                <a16:creationId xmlns:a16="http://schemas.microsoft.com/office/drawing/2014/main" id="{A4B055B9-FFFB-46CB-BABF-0084D21C1399}"/>
+                <a16:creationId xmlns:a16="http://schemas.microsoft.com/office/drawing/2014/main" id="{F9457C08-EEAB-4DA5-8158-EB5DDE25FF36}"/>
               </a:ext>
             </a:extLst>
           </p:cNvPr>
@@ -14643,7 +14699,7 @@
           <p:cNvPr id="4" name="">
             <a:extLst xmlns:a="http://schemas.openxmlformats.org/drawingml/2006/main">
               <a:ext uri="{FF2B5EF4-FFF2-40B4-BE49-F238E27FC236}">
-                <a16:creationId xmlns:a16="http://schemas.microsoft.com/office/drawing/2014/main" id="{C309DB9D-CE07-4F3A-935B-FBFB15F78DA7}"/>
+                <a16:creationId xmlns:a16="http://schemas.microsoft.com/office/drawing/2014/main" id="{8C45899A-FE4F-40E9-BFAB-42744DBED2A3}"/>
               </a:ext>
             </a:extLst>
           </p:cNvPr>
@@ -14710,7 +14766,7 @@
           <p:cNvPr id="5" name="">
             <a:extLst xmlns:a="http://schemas.openxmlformats.org/drawingml/2006/main">
               <a:ext uri="{FF2B5EF4-FFF2-40B4-BE49-F238E27FC236}">
-                <a16:creationId xmlns:a16="http://schemas.microsoft.com/office/drawing/2014/main" id="{41DA2BB9-8687-4947-8D0C-FB7D64ECC2DF}"/>
+                <a16:creationId xmlns:a16="http://schemas.microsoft.com/office/drawing/2014/main" id="{F708DEF6-4729-437A-8EBD-219E09850F80}"/>
               </a:ext>
             </a:extLst>
           </p:cNvPr>
@@ -14743,7 +14799,7 @@
           <p:cNvPr id="6" name="">
             <a:extLst xmlns:a="http://schemas.openxmlformats.org/drawingml/2006/main">
               <a:ext uri="{FF2B5EF4-FFF2-40B4-BE49-F238E27FC236}">
-                <a16:creationId xmlns:a16="http://schemas.microsoft.com/office/drawing/2014/main" id="{21705A0C-487B-444D-9BE2-85DF48BA581B}"/>
+                <a16:creationId xmlns:a16="http://schemas.microsoft.com/office/drawing/2014/main" id="{FE469913-B942-4507-B3EA-5CD01150776E}"/>
               </a:ext>
             </a:extLst>
           </p:cNvPr>
@@ -14800,7 +14856,7 @@
                 <a:ea typeface="Arial"/>
                 <a:cs typeface="Arial"/>
               </a:rPr>
-              <a:t>Public API ingestion</a:t>
+              <a:t>Real-time API and RabbitMQ</a:t>
             </a:r>
           </a:p>
         </p:txBody>
@@ -14810,7 +14866,7 @@
           <p:cNvPr id="7" name="">
             <a:extLst xmlns:a="http://schemas.openxmlformats.org/drawingml/2006/main">
               <a:ext uri="{FF2B5EF4-FFF2-40B4-BE49-F238E27FC236}">
-                <a16:creationId xmlns:a16="http://schemas.microsoft.com/office/drawing/2014/main" id="{369C0BC7-A2CF-4CE2-9855-05D1E8F9C3BB}"/>
+                <a16:creationId xmlns:a16="http://schemas.microsoft.com/office/drawing/2014/main" id="{3ADB21BC-CFEF-4559-A9DC-1ACEF21D7706}"/>
               </a:ext>
             </a:extLst>
           </p:cNvPr>
@@ -14867,7 +14923,7 @@
                 <a:ea typeface="Arial"/>
                 <a:cs typeface="Arial"/>
               </a:rPr>
-              <a:t>194 products, 208 carts and 800 flattened cart lines</a:t>
+              <a:t>FastAPI validation, publisher confirms, manual ack and event-ID deduplication</a:t>
             </a:r>
           </a:p>
         </p:txBody>
@@ -14877,7 +14933,7 @@
           <p:cNvPr id="8" name="">
             <a:extLst xmlns:a="http://schemas.openxmlformats.org/drawingml/2006/main">
               <a:ext uri="{FF2B5EF4-FFF2-40B4-BE49-F238E27FC236}">
-                <a16:creationId xmlns:a16="http://schemas.microsoft.com/office/drawing/2014/main" id="{73DB10D7-456C-45AE-919D-CDC62E54CFD7}"/>
+                <a16:creationId xmlns:a16="http://schemas.microsoft.com/office/drawing/2014/main" id="{4B8F3A10-7FA0-4B45-B865-6FF0A96DE4D3}"/>
               </a:ext>
             </a:extLst>
           </p:cNvPr>
@@ -14936,7 +14992,7 @@
                 <a:ea typeface="Arial"/>
                 <a:cs typeface="Arial"/>
               </a:rPr>
-              <a:t>Raw JSON, CSV snapshot and DuckDB table</a:t>
+              <a:t>25-event UI check plus 4 automated tests</a:t>
             </a:r>
           </a:p>
         </p:txBody>
@@ -14946,7 +15002,7 @@
           <p:cNvPr id="9" name="">
             <a:extLst xmlns:a="http://schemas.openxmlformats.org/drawingml/2006/main">
               <a:ext uri="{FF2B5EF4-FFF2-40B4-BE49-F238E27FC236}">
-                <a16:creationId xmlns:a16="http://schemas.microsoft.com/office/drawing/2014/main" id="{133F2197-9820-43B7-AF83-2ED72AC84DA2}"/>
+                <a16:creationId xmlns:a16="http://schemas.microsoft.com/office/drawing/2014/main" id="{5FF089CC-8F03-40D3-902E-E82953FF50C1}"/>
               </a:ext>
             </a:extLst>
           </p:cNvPr>
@@ -15013,7 +15069,7 @@
           <p:cNvPr id="10" name="">
             <a:extLst xmlns:a="http://schemas.openxmlformats.org/drawingml/2006/main">
               <a:ext uri="{FF2B5EF4-FFF2-40B4-BE49-F238E27FC236}">
-                <a16:creationId xmlns:a16="http://schemas.microsoft.com/office/drawing/2014/main" id="{D4C74849-26D1-409A-AE52-4B0F1629C4F7}"/>
+                <a16:creationId xmlns:a16="http://schemas.microsoft.com/office/drawing/2014/main" id="{06A2FF0A-0CD2-4C7E-9C57-76B28489EFC2}"/>
               </a:ext>
             </a:extLst>
           </p:cNvPr>
@@ -15046,7 +15102,7 @@
           <p:cNvPr id="11" name="">
             <a:extLst xmlns:a="http://schemas.openxmlformats.org/drawingml/2006/main">
               <a:ext uri="{FF2B5EF4-FFF2-40B4-BE49-F238E27FC236}">
-                <a16:creationId xmlns:a16="http://schemas.microsoft.com/office/drawing/2014/main" id="{821C4BD1-987F-4F4D-B8B6-985AC91CE271}"/>
+                <a16:creationId xmlns:a16="http://schemas.microsoft.com/office/drawing/2014/main" id="{45F16E32-09A6-4C00-893D-4A5426EFB8DE}"/>
               </a:ext>
             </a:extLst>
           </p:cNvPr>
@@ -15113,7 +15169,7 @@
           <p:cNvPr id="12" name="">
             <a:extLst xmlns:a="http://schemas.openxmlformats.org/drawingml/2006/main">
               <a:ext uri="{FF2B5EF4-FFF2-40B4-BE49-F238E27FC236}">
-                <a16:creationId xmlns:a16="http://schemas.microsoft.com/office/drawing/2014/main" id="{6E5135BF-831E-4C96-8C2D-735166ABF58A}"/>
+                <a16:creationId xmlns:a16="http://schemas.microsoft.com/office/drawing/2014/main" id="{C07A759F-9A2D-490D-9096-529329C94611}"/>
               </a:ext>
             </a:extLst>
           </p:cNvPr>
@@ -15170,7 +15226,7 @@
                 <a:ea typeface="Arial"/>
                 <a:cs typeface="Arial"/>
               </a:rPr>
-              <a:t>Deployment, Service, PVC, health probes and HPA</a:t>
+              <a:t>RabbitMQ, API-consumer, simulator, dashboard, PVC, probes and HPA</a:t>
             </a:r>
           </a:p>
         </p:txBody>
@@ -15180,7 +15236,7 @@
           <p:cNvPr id="13" name="">
             <a:extLst xmlns:a="http://schemas.openxmlformats.org/drawingml/2006/main">
               <a:ext uri="{FF2B5EF4-FFF2-40B4-BE49-F238E27FC236}">
-                <a16:creationId xmlns:a16="http://schemas.microsoft.com/office/drawing/2014/main" id="{04936E6B-1A74-43EA-985B-96670C35F0B1}"/>
+                <a16:creationId xmlns:a16="http://schemas.microsoft.com/office/drawing/2014/main" id="{AB53B332-3AEC-4B73-8948-2D4223F312B4}"/>
               </a:ext>
             </a:extLst>
           </p:cNvPr>
@@ -15239,7 +15295,7 @@
                 <a:ea typeface="Arial"/>
                 <a:cs typeface="Arial"/>
               </a:rPr>
-              <a:t>One Kustomize command applies all resources</a:t>
+              <a:t>Kustomize renders the complete stream</a:t>
             </a:r>
           </a:p>
         </p:txBody>
@@ -15249,7 +15305,7 @@
           <p:cNvPr id="14" name="">
             <a:extLst xmlns:a="http://schemas.openxmlformats.org/drawingml/2006/main">
               <a:ext uri="{FF2B5EF4-FFF2-40B4-BE49-F238E27FC236}">
-                <a16:creationId xmlns:a16="http://schemas.microsoft.com/office/drawing/2014/main" id="{440D187E-DCB3-443C-92C2-364E340400A4}"/>
+                <a16:creationId xmlns:a16="http://schemas.microsoft.com/office/drawing/2014/main" id="{F78CF3A7-50AA-49C9-AB9C-B532A16461E3}"/>
               </a:ext>
             </a:extLst>
           </p:cNvPr>
@@ -15316,7 +15372,7 @@
           <p:cNvPr id="15" name="">
             <a:extLst xmlns:a="http://schemas.openxmlformats.org/drawingml/2006/main">
               <a:ext uri="{FF2B5EF4-FFF2-40B4-BE49-F238E27FC236}">
-                <a16:creationId xmlns:a16="http://schemas.microsoft.com/office/drawing/2014/main" id="{CDE1B7FF-59FF-4826-8B30-84243EFF0C19}"/>
+                <a16:creationId xmlns:a16="http://schemas.microsoft.com/office/drawing/2014/main" id="{066F7E88-B6EE-4EA2-B46A-AF82D6798544}"/>
               </a:ext>
             </a:extLst>
           </p:cNvPr>
@@ -15349,7 +15405,7 @@
           <p:cNvPr id="16" name="">
             <a:extLst xmlns:a="http://schemas.openxmlformats.org/drawingml/2006/main">
               <a:ext uri="{FF2B5EF4-FFF2-40B4-BE49-F238E27FC236}">
-                <a16:creationId xmlns:a16="http://schemas.microsoft.com/office/drawing/2014/main" id="{A711185F-D444-40BD-A5B0-C2E81C164603}"/>
+                <a16:creationId xmlns:a16="http://schemas.microsoft.com/office/drawing/2014/main" id="{E75BAD71-9603-4A31-9FC7-2A07E18FF131}"/>
               </a:ext>
             </a:extLst>
           </p:cNvPr>
@@ -15416,7 +15472,7 @@
           <p:cNvPr id="17" name="">
             <a:extLst xmlns:a="http://schemas.openxmlformats.org/drawingml/2006/main">
               <a:ext uri="{FF2B5EF4-FFF2-40B4-BE49-F238E27FC236}">
-                <a16:creationId xmlns:a16="http://schemas.microsoft.com/office/drawing/2014/main" id="{9AB0C475-E5D0-4F38-9485-04DB531970AB}"/>
+                <a16:creationId xmlns:a16="http://schemas.microsoft.com/office/drawing/2014/main" id="{DA9F3BF2-A1CE-48B6-AF22-06BD1A022B7B}"/>
               </a:ext>
             </a:extLst>
           </p:cNvPr>
@@ -15483,7 +15539,7 @@
           <p:cNvPr id="18" name="">
             <a:extLst xmlns:a="http://schemas.openxmlformats.org/drawingml/2006/main">
               <a:ext uri="{FF2B5EF4-FFF2-40B4-BE49-F238E27FC236}">
-                <a16:creationId xmlns:a16="http://schemas.microsoft.com/office/drawing/2014/main" id="{935E7F11-C0B0-4719-8856-281AEF458874}"/>
+                <a16:creationId xmlns:a16="http://schemas.microsoft.com/office/drawing/2014/main" id="{CD2C20EA-1030-4F7D-9B68-954F489443D3}"/>
               </a:ext>
             </a:extLst>
           </p:cNvPr>
@@ -15552,7 +15608,7 @@
           <p:cNvPr id="19" name="">
             <a:extLst xmlns:a="http://schemas.openxmlformats.org/drawingml/2006/main">
               <a:ext uri="{FF2B5EF4-FFF2-40B4-BE49-F238E27FC236}">
-                <a16:creationId xmlns:a16="http://schemas.microsoft.com/office/drawing/2014/main" id="{3E6E9A3F-B5AC-43D2-9EA2-21C946EFEF1F}"/>
+                <a16:creationId xmlns:a16="http://schemas.microsoft.com/office/drawing/2014/main" id="{1FA6B5C1-D6B5-49C4-8208-B9EDC80F1A53}"/>
               </a:ext>
             </a:extLst>
           </p:cNvPr>
@@ -15609,7 +15665,7 @@
                 <a:ea typeface="Arial"/>
                 <a:cs typeface="Arial"/>
               </a:rPr>
-              <a:t>Kubernetes caution</a:t>
+              <a:t>Concurrency design</a:t>
             </a:r>
           </a:p>
         </p:txBody>
@@ -15619,7 +15675,7 @@
           <p:cNvPr id="20" name="">
             <a:extLst xmlns:a="http://schemas.openxmlformats.org/drawingml/2006/main">
               <a:ext uri="{FF2B5EF4-FFF2-40B4-BE49-F238E27FC236}">
-                <a16:creationId xmlns:a16="http://schemas.microsoft.com/office/drawing/2014/main" id="{883B41C2-550D-4F3C-8691-21D702D7804E}"/>
+                <a16:creationId xmlns:a16="http://schemas.microsoft.com/office/drawing/2014/main" id="{B8F05890-3B7F-4510-A062-53102CB0C60D}"/>
               </a:ext>
             </a:extLst>
           </p:cNvPr>
@@ -15676,7 +15732,7 @@
                 <a:ea typeface="Arial"/>
                 <a:cs typeface="Arial"/>
               </a:rPr>
-              <a:t>The HPA scales dashboard pods. A writable DuckDB file still needs single-writer discipline.</a:t>
+              <a:t>The API embeds the consumer so one process owns the writable real-time DuckDB file.</a:t>
             </a:r>
           </a:p>
         </p:txBody>
@@ -15686,7 +15742,7 @@
           <p:cNvPr id="21" name="">
             <a:extLst xmlns:a="http://schemas.openxmlformats.org/drawingml/2006/main">
               <a:ext uri="{FF2B5EF4-FFF2-40B4-BE49-F238E27FC236}">
-                <a16:creationId xmlns:a16="http://schemas.microsoft.com/office/drawing/2014/main" id="{14547F3A-2598-416A-A7A4-17D7E18E636D}"/>
+                <a16:creationId xmlns:a16="http://schemas.microsoft.com/office/drawing/2014/main" id="{821375CA-B3E4-46F7-BE08-34E7B85B5B2F}"/>
               </a:ext>
             </a:extLst>
           </p:cNvPr>
@@ -15719,7 +15775,7 @@
           <p:cNvPr id="22" name="">
             <a:extLst xmlns:a="http://schemas.openxmlformats.org/drawingml/2006/main">
               <a:ext uri="{FF2B5EF4-FFF2-40B4-BE49-F238E27FC236}">
-                <a16:creationId xmlns:a16="http://schemas.microsoft.com/office/drawing/2014/main" id="{7C7A7A45-4BB7-4445-9929-5985F434EC7E}"/>
+                <a16:creationId xmlns:a16="http://schemas.microsoft.com/office/drawing/2014/main" id="{1E9BE125-D694-47A2-A376-BEE2E17DCC7E}"/>
               </a:ext>
             </a:extLst>
           </p:cNvPr>
@@ -15786,19 +15842,19 @@
           <p:cNvPr id="23" name="">
             <a:extLst xmlns:a="http://schemas.openxmlformats.org/drawingml/2006/main">
               <a:ext uri="{FF2B5EF4-FFF2-40B4-BE49-F238E27FC236}">
-                <a16:creationId xmlns:a16="http://schemas.microsoft.com/office/drawing/2014/main" id="{382BCEFA-DEF5-4406-878D-D420EE934A18}"/>
-              </a:ext>
-            </a:extLst>
-          </p:cNvPr>
-          <p:cNvSpPr>
-            <a:spLocks xmlns:a="http://schemas.openxmlformats.org/drawingml/2006/main" noGrp="1"/>
-          </p:cNvSpPr>
-          <p:nvPr/>
-        </p:nvSpPr>
-        <p:spPr>
-          <a:xfrm xmlns:a="http://schemas.openxmlformats.org/drawingml/2006/main">
-            <a:off x="7524750" y="6524625"/>
-            <a:ext cx="3981450" cy="171450"/>
+                <a16:creationId xmlns:a16="http://schemas.microsoft.com/office/drawing/2014/main" id="{2925363C-9BB5-4AFC-8A86-72E0E8441A96}"/>
+              </a:ext>
+            </a:extLst>
+          </p:cNvPr>
+          <p:cNvSpPr>
+            <a:spLocks xmlns:a="http://schemas.openxmlformats.org/drawingml/2006/main" noGrp="1"/>
+          </p:cNvSpPr>
+          <p:nvPr/>
+        </p:nvSpPr>
+        <p:spPr>
+          <a:xfrm xmlns:a="http://schemas.openxmlformats.org/drawingml/2006/main">
+            <a:off x="7143750" y="6524625"/>
+            <a:ext cx="4362450" cy="171450"/>
           </a:xfrm>
           <a:prstGeom xmlns:a="http://schemas.openxmlformats.org/drawingml/2006/main" prst="rect">
             <a:avLst/>
@@ -15843,7 +15899,7 @@
                 <a:ea typeface="Arial"/>
                 <a:cs typeface="Arial"/>
               </a:rPr>
-              <a:t>Python  |  SQL  |  DuckDB  |  Streamlit</a:t>
+              <a:t>DuckDB  |  FastAPI  |  RabbitMQ  |  Streamlit</a:t>
             </a:r>
           </a:p>
         </p:txBody>
@@ -15851,7 +15907,7 @@
     </p:spTree>
     <p:extLst>
       <p:ext uri="{BB962C8B-B14F-4D97-AF65-F5344CB8AC3E}">
-        <p14:creationId xmlns:p14="http://schemas.microsoft.com/office/powerpoint/2010/main" val="316401297"/>
+        <p14:creationId xmlns:p14="http://schemas.microsoft.com/office/powerpoint/2010/main" val="1738715366"/>
       </p:ext>
     </p:extLst>
   </p:cSld>

</xml_diff>